<commit_message>
Revamp ICAIBD presentation: structure, trace example, and styling
- Reframe deck around two problems: break groupthink (1) + recognize
  the rare-correct (2); tag every method slide with its problem number
- Reorder slides into the (1)/(2) narrative; move walkthrough to backup
- Add slide 2 example task render (2d0172a1) and a raw JSON trace slide
  showing the winning candidate + judge rationale from the V7 logs
- Expand negative results from 2 to 5; clarify generalization claim
  (reasoning signals correctness, not just checkable answers)
- Filter methodology matrix to the 130 full-coverage instances; rename
  Overall->Judges; drop row labels; enlarge headers
- Beautify PDF: Boadilla/dolphin theme, Helvetica, deep-blue accent
  palette, custom title page and frametitle, unified callout boxes
- Fix headline result row (Gemini 3 Pro 31.1%), private (not
  semi-private), Gemini 3.1 Deep Think, Opus 4.7

Co-Authored-By: Claude Opus 4.8 (1M context) <noreply@anthropic.com>
</commit_message>
<xml_diff>
--- a/presentation/slides.pptx
+++ b/presentation/slides.pptx
@@ -5,7 +5,7 @@
     <p:sldMasterId id="2147483648" r:id="rId1"/>
   </p:sldMasterIdLst>
   <p:notesMasterIdLst>
-    <p:notesMasterId r:id="rId18"/>
+    <p:notesMasterId r:id="rId22"/>
   </p:notesMasterIdLst>
   <p:sldIdLst>
     <p:sldId id="256" r:id="rId2"/>
@@ -24,6 +24,10 @@
     <p:sldId id="269" r:id="rId15"/>
     <p:sldId id="270" r:id="rId16"/>
     <p:sldId id="271" r:id="rId17"/>
+    <p:sldId id="272" r:id="rId18"/>
+    <p:sldId id="273" r:id="rId19"/>
+    <p:sldId id="274" r:id="rId20"/>
+    <p:sldId id="275" r:id="rId21"/>
   </p:sldIdLst>
   <p:sldSz cx="9144000" cy="5143500" type="screen16x9"/>
   <p:notesSz cx="6858000" cy="9144000"/>
@@ -621,7 +625,7 @@
             </a:pPr>
             <a:r>
               <a:rPr/>
-              <a:t>The oracle number (86.2%) is the most honest framing of the system’s ceiling: it says generation is in good shape and selection is the next frontier. Tie back: of the 39 failures, 17 are selection — that’s where the headroom is.</a:t>
+              <a:t>Payoff slide for the judging architecture. Excerpts are verbatim from the logged run. Left: the winning image candidate reasoned about “frames vs markers” and “topological normalization” — the model’s own language, not a forced template. Right: the judge independently arrived at the same mechanic and named the rare-correct candidate “Solution 10” while keeping “Solution 6/7” as the safer pass@2 fallback. Three independent judges all picked the correct grid as #1 — full alignment. The point: the judge does not vote on outputs, it reads the reasoning of all 29 candidates and selects the trace whose argument is most coherent against the training pairs. That’s what makes minority recovery possible.</a:t>
             </a:r>
           </a:p>
         </p:txBody>
@@ -643,7 +647,7 @@
           <a:p>
             <a:fld id="{18BDFEC3-8487-43E8-A154-7C12CBC1FFF2}" type="slidenum">
               <a:rPr lang="en-US"/>
-              <a:t>11</a:t>
+              <a:t>13</a:t>
             </a:fld>
             <a:endParaRPr lang="en-US"/>
           </a:p>
@@ -703,7 +707,23 @@
             </a:pPr>
             <a:r>
               <a:rPr/>
-              <a:t>Most counter-intuitive findings in the paper — audiences love negative results because they save them time. Frame these as design constraints we discovered the hard way: every time we added “helpful” structure, scores dropped on the tasks that mattered.</a:t>
+              <a:t>The chart is dense — spend the first 20s teaching the audience how to read it. Point at the top band (“look at these rows: green across the board — easy tasks”), then the middle band (“but </a:t>
+            </a:r>
+            <a:r>
+              <a:rPr i="1"/>
+              <a:t>here</a:t>
+            </a:r>
+            <a:r>
+              <a:rPr/>
+              <a:t> — mostly red rows with only one or two green cells. That’s modality diversity doing the work”), then the bottom (“and these are the generation failures — no modality solved them”). The 86.2% oracle number is the most honest framing of the system’s ceiling: generation is in good shape; selection is the next frontier. Tie back: of the 39 failures, 17 are </a:t>
+            </a:r>
+            <a:r>
+              <a:rPr i="1"/>
+              <a:t>selection</a:t>
+            </a:r>
+            <a:r>
+              <a:rPr/>
+              <a:t> — that’s where the headroom is.</a:t>
             </a:r>
           </a:p>
         </p:txBody>
@@ -725,7 +745,7 @@
           <a:p>
             <a:fld id="{18BDFEC3-8487-43E8-A154-7C12CBC1FFF2}" type="slidenum">
               <a:rPr lang="en-US"/>
-              <a:t>12</a:t>
+              <a:t>14</a:t>
             </a:fld>
             <a:endParaRPr lang="en-US"/>
           </a:p>
@@ -785,7 +805,7 @@
             </a:pPr>
             <a:r>
               <a:rPr/>
-              <a:t>Close on the three-bullet recap. Then invite questions. If asked about cost, jump to backup slide on cost breakdown. If asked about failure modes, jump to backup slide on failure decomposition. If asked why three judges, jump to the third backup slide.</a:t>
+              <a:t>Most counter-intuitive findings in the paper — audiences love negative results because they save them time. Frame these as design constraints we discovered the hard way: every time we added “helpful” structure, scores dropped on the tasks that mattered. (1) and (2) are the big two — spend more time there. (3) is a useful counterpoint to anyone who’s spent six months building a multi-stage agent. (4) will surprise the LLM-engineering audience used to JSON-mode being a default. (5) is the most visually intuitive — mention that we render the grids with intentional jitter, like a hand-drawn sketch, because pixel-perfect renderings made the model treat the image as a lossless encoding and fall back on numerical reasoning instead of visual.</a:t>
             </a:r>
           </a:p>
         </p:txBody>
@@ -807,7 +827,7 @@
           <a:p>
             <a:fld id="{18BDFEC3-8487-43E8-A154-7C12CBC1FFF2}" type="slidenum">
               <a:rPr lang="en-US"/>
-              <a:t>13</a:t>
+              <a:t>15</a:t>
             </a:fld>
             <a:endParaRPr lang="en-US"/>
           </a:p>
@@ -867,7 +887,15 @@
             </a:pPr>
             <a:r>
               <a:rPr/>
-              <a:t>Backup only. Skip unless asked.</a:t>
+              <a:t>Close strong on the generalization claim. Pause on the headline and let it land. Recap (1) and (2). Key clarification on “where this generalizes”: this is </a:t>
+            </a:r>
+            <a:r>
+              <a:rPr i="1"/>
+              <a:t>not</a:t>
+            </a:r>
+            <a:r>
+              <a:rPr/>
+              <a:t> only for problems with checkable answers. It also works whenever the reasoning itself carries credible signal — as in ARC, where the judges never see the test output and instead assess each trace’s coherence against the training pairs. The audience should think about applying this anywhere a careful reader could tell sound reasoning from rationalization: code review, legal arguments, scientific hypotheses, design critiques. The closing number reminds them this isn’t speculative: verified result, almost 20 points over the best standalone model. Then invite questions.</a:t>
             </a:r>
           </a:p>
         </p:txBody>
@@ -889,7 +917,7 @@
           <a:p>
             <a:fld id="{18BDFEC3-8487-43E8-A154-7C12CBC1FFF2}" type="slidenum">
               <a:rPr lang="en-US"/>
-              <a:t>14</a:t>
+              <a:t>16</a:t>
             </a:fld>
             <a:endParaRPr lang="en-US"/>
           </a:p>
@@ -949,7 +977,35 @@
             </a:pPr>
             <a:r>
               <a:rPr/>
-              <a:t>Backup only. Skip unless asked.</a:t>
+              <a:t>This is the pedagogical heart of the talk. Don’t rush. Budget 2:30.</a:t>
+            </a:r>
+          </a:p>
+          <a:p>
+            <a:pPr lvl="0" indent="0" marL="0">
+              <a:buNone/>
+            </a:pPr>
+          </a:p>
+          <a:p>
+            <a:pPr lvl="0" indent="0" marL="0">
+              <a:buNone/>
+            </a:pPr>
+            <a:r>
+              <a:rPr/>
+              <a:t>Script: (0:30) Show the task; let the audience attempt it mentally. (0:30) Show what TEXT candidates produce — note the dominant (wrong) interpretation. (0:30) Show what IMAGE candidates produce — note where they diverge from Text. (0:30) Show what CODE candidates produce — note any structurally different hypothesis. (0:30) Reveal the judge’s reasoning: which cluster it rejected, which minority it elevated, why pass@2 lets it hedge.</a:t>
+            </a:r>
+          </a:p>
+          <a:p>
+            <a:pPr lvl="0" indent="0" marL="0">
+              <a:buNone/>
+            </a:pPr>
+          </a:p>
+          <a:p>
+            <a:pPr lvl="0" indent="0" marL="0">
+              <a:buNone/>
+            </a:pPr>
+            <a:r>
+              <a:rPr/>
+              <a:t>If tight on time, drop the IMAGE step and go Text → Code → Judge — the contrast is sharpest there. End with: “This is what ‘modalities as search operators’ looks like in practice.”</a:t>
             </a:r>
           </a:p>
         </p:txBody>
@@ -971,7 +1027,7 @@
           <a:p>
             <a:fld id="{18BDFEC3-8487-43E8-A154-7C12CBC1FFF2}" type="slidenum">
               <a:rPr lang="en-US"/>
-              <a:t>15</a:t>
+              <a:t>17</a:t>
             </a:fld>
             <a:endParaRPr lang="en-US"/>
           </a:p>
@@ -1053,7 +1109,171 @@
           <a:p>
             <a:fld id="{18BDFEC3-8487-43E8-A154-7C12CBC1FFF2}" type="slidenum">
               <a:rPr lang="en-US"/>
-              <a:t>16</a:t>
+              <a:t>18</a:t>
+            </a:fld>
+            <a:endParaRPr lang="en-US"/>
+          </a:p>
+        </p:txBody>
+      </p:sp>
+    </p:spTree>
+  </p:cSld>
+</p:notes>
+</file>
+
+<file path=ppt/notesSlides/notesSlide16.xml><?xml version="1.0" encoding="utf-8"?>
+<p:notes xmlns:a="http://schemas.openxmlformats.org/drawingml/2006/main" xmlns:r="http://schemas.openxmlformats.org/officeDocument/2006/relationships" xmlns:p="http://schemas.openxmlformats.org/presentationml/2006/main">
+  <p:cSld>
+    <p:spTree>
+      <p:nvGrpSpPr>
+        <p:cNvPr id="1" name=""/>
+        <p:cNvGrpSpPr/>
+        <p:nvPr/>
+      </p:nvGrpSpPr>
+      <p:grpSpPr>
+        <a:xfrm>
+          <a:off x="0" y="0"/>
+          <a:ext cx="0" cy="0"/>
+          <a:chOff x="0" y="0"/>
+          <a:chExt cx="0" cy="0"/>
+        </a:xfrm>
+      </p:grpSpPr>
+      <p:sp>
+        <p:nvSpPr>
+          <p:cNvPr id="2" name="Slide Image Placeholder 1"/>
+          <p:cNvSpPr>
+            <a:spLocks noGrp="1" noRot="1" noChangeAspect="1"/>
+          </p:cNvSpPr>
+          <p:nvPr>
+            <p:ph type="sldImg"/>
+          </p:nvPr>
+        </p:nvSpPr>
+        <p:spPr/>
+      </p:sp>
+      <p:sp>
+        <p:nvSpPr>
+          <p:cNvPr id="3" name="Notes Placeholder 2"/>
+          <p:cNvSpPr>
+            <a:spLocks noGrp="1"/>
+          </p:cNvSpPr>
+          <p:nvPr>
+            <p:ph type="body" idx="1"/>
+          </p:nvPr>
+        </p:nvSpPr>
+        <p:spPr/>
+        <p:txBody>
+          <a:bodyPr/>
+          <a:lstStyle/>
+          <a:p>
+            <a:pPr lvl="0" indent="0" marL="0">
+              <a:buNone/>
+            </a:pPr>
+            <a:r>
+              <a:rPr/>
+              <a:t>Backup only. Skip unless asked.</a:t>
+            </a:r>
+          </a:p>
+        </p:txBody>
+      </p:sp>
+      <p:sp>
+        <p:nvSpPr>
+          <p:cNvPr id="4" name="Slide Number Placeholder 3"/>
+          <p:cNvSpPr>
+            <a:spLocks noGrp="1"/>
+          </p:cNvSpPr>
+          <p:nvPr>
+            <p:ph type="sldNum" sz="quarter" idx="10"/>
+          </p:nvPr>
+        </p:nvSpPr>
+        <p:spPr/>
+        <p:txBody>
+          <a:bodyPr/>
+          <a:lstStyle/>
+          <a:p>
+            <a:fld id="{18BDFEC3-8487-43E8-A154-7C12CBC1FFF2}" type="slidenum">
+              <a:rPr lang="en-US"/>
+              <a:t>19</a:t>
+            </a:fld>
+            <a:endParaRPr lang="en-US"/>
+          </a:p>
+        </p:txBody>
+      </p:sp>
+    </p:spTree>
+  </p:cSld>
+</p:notes>
+</file>
+
+<file path=ppt/notesSlides/notesSlide17.xml><?xml version="1.0" encoding="utf-8"?>
+<p:notes xmlns:a="http://schemas.openxmlformats.org/drawingml/2006/main" xmlns:r="http://schemas.openxmlformats.org/officeDocument/2006/relationships" xmlns:p="http://schemas.openxmlformats.org/presentationml/2006/main">
+  <p:cSld>
+    <p:spTree>
+      <p:nvGrpSpPr>
+        <p:cNvPr id="1" name=""/>
+        <p:cNvGrpSpPr/>
+        <p:nvPr/>
+      </p:nvGrpSpPr>
+      <p:grpSpPr>
+        <a:xfrm>
+          <a:off x="0" y="0"/>
+          <a:ext cx="0" cy="0"/>
+          <a:chOff x="0" y="0"/>
+          <a:chExt cx="0" cy="0"/>
+        </a:xfrm>
+      </p:grpSpPr>
+      <p:sp>
+        <p:nvSpPr>
+          <p:cNvPr id="2" name="Slide Image Placeholder 1"/>
+          <p:cNvSpPr>
+            <a:spLocks noGrp="1" noRot="1" noChangeAspect="1"/>
+          </p:cNvSpPr>
+          <p:nvPr>
+            <p:ph type="sldImg"/>
+          </p:nvPr>
+        </p:nvSpPr>
+        <p:spPr/>
+      </p:sp>
+      <p:sp>
+        <p:nvSpPr>
+          <p:cNvPr id="3" name="Notes Placeholder 2"/>
+          <p:cNvSpPr>
+            <a:spLocks noGrp="1"/>
+          </p:cNvSpPr>
+          <p:nvPr>
+            <p:ph type="body" idx="1"/>
+          </p:nvPr>
+        </p:nvSpPr>
+        <p:spPr/>
+        <p:txBody>
+          <a:bodyPr/>
+          <a:lstStyle/>
+          <a:p>
+            <a:pPr lvl="0" indent="0" marL="0">
+              <a:buNone/>
+            </a:pPr>
+            <a:r>
+              <a:rPr/>
+              <a:t>Backup only. Skip unless asked.</a:t>
+            </a:r>
+          </a:p>
+        </p:txBody>
+      </p:sp>
+      <p:sp>
+        <p:nvSpPr>
+          <p:cNvPr id="4" name="Slide Number Placeholder 3"/>
+          <p:cNvSpPr>
+            <a:spLocks noGrp="1"/>
+          </p:cNvSpPr>
+          <p:nvPr>
+            <p:ph type="sldNum" sz="quarter" idx="10"/>
+          </p:nvPr>
+        </p:nvSpPr>
+        <p:spPr/>
+        <p:txBody>
+          <a:bodyPr/>
+          <a:lstStyle/>
+          <a:p>
+            <a:fld id="{18BDFEC3-8487-43E8-A154-7C12CBC1FFF2}" type="slidenum">
+              <a:rPr lang="en-US"/>
+              <a:t>20</a:t>
             </a:fld>
             <a:endParaRPr lang="en-US"/>
           </a:p>
@@ -1277,7 +1497,7 @@
             </a:pPr>
             <a:r>
               <a:rPr/>
-              <a:t>This is the reframe that unlocks the whole architecture. If they take only one thing home before the method, take this one. Concrete number to drop: of our 39 failure instances, only 21 are genuine generation failures — 17 are </a:t>
+              <a:t>The architecture has to solve two problems, not one. First: counter the groupthink — left to themselves, frontier models cluster on the same wrong interpretation, so the system has to deliberately diversify generation. Second: even when a correct candidate does exist in the pool, majority voting will discard it as an outlier — so selection has to read the reasoning, not just count votes. Concrete number to drop: of our 39 failure instances, 21 are genuine generation failures and 17 are </a:t>
             </a:r>
             <a:r>
               <a:rPr i="1"/>
@@ -1285,7 +1505,7 @@
             </a:r>
             <a:r>
               <a:rPr/>
-              <a:t> failures where a correct candidate exists in the pool but is not chosen. Set up the next slide: if the correct answer is rare, we need to (a) make sure we generate it, and (b) recognize it without majority-counting.</a:t>
+              <a:t> failures where a correct candidate exists in the pool but is not chosen. The two failure modes are roughly the same size — neither dominates.</a:t>
             </a:r>
           </a:p>
         </p:txBody>
@@ -1449,15 +1669,7 @@
             </a:pPr>
             <a:r>
               <a:rPr/>
-              <a:t>One pass through the diagram, max 50 seconds. Audience just needs the shape. Highlight: judges see </a:t>
-            </a:r>
-            <a:r>
-              <a:rPr i="1"/>
-              <a:t>full reasoning traces</a:t>
-            </a:r>
-            <a:r>
-              <a:rPr/>
-              <a:t>, not just final answers — this is what enables minority recovery. Mention early-stop to pre-empt the obvious cost objection.</a:t>
+              <a:t>Don’t list every configuration — the point is the structure: three families crossed with three models. The “minimal prompts” bullet is a callback you’ll cash in on the negative-results slide.</a:t>
             </a:r>
           </a:p>
         </p:txBody>
@@ -1539,7 +1751,31 @@
             </a:pPr>
             <a:r>
               <a:rPr/>
-              <a:t>Don’t list every configuration — the point is the structure: three families crossed with three models. The “minimal prompts” bullet is a callback you’ll cash in on the negative-results slide.</a:t>
+              <a:t>The +7 number is the empirical payoff of the architecture. Say it slowly. The synthesis case is </a:t>
+            </a:r>
+            <a:r>
+              <a:rPr i="1"/>
+              <a:t>qualitatively</a:t>
+            </a:r>
+            <a:r>
+              <a:rPr/>
+              <a:t> different — it shows the system can sometimes </a:t>
+            </a:r>
+            <a:r>
+              <a:rPr i="1"/>
+              <a:t>construct</a:t>
+            </a:r>
+            <a:r>
+              <a:rPr/>
+              <a:t> a correct answer rather than just </a:t>
+            </a:r>
+            <a:r>
+              <a:rPr i="1"/>
+              <a:t>select</a:t>
+            </a:r>
+            <a:r>
+              <a:rPr/>
+              <a:t> one. Rare (n=1) but a proof-of-possibility for compositional repair. If time allows, quote the judge rationale from dfadab01:1: “Some solvers assume a stamp must fit fully. Others assume stamps are clipped at the border…” — shows the judge reasoning about disagreement explicitly.</a:t>
             </a:r>
           </a:p>
         </p:txBody>
@@ -1621,31 +1857,15 @@
             </a:pPr>
             <a:r>
               <a:rPr/>
-              <a:t>The +7 number is the empirical payoff of the architecture. Say it slowly. The synthesis case is </a:t>
+              <a:t>One pass through the diagram, max 50 seconds. Audience just needs the shape. Highlight: judges see </a:t>
             </a:r>
             <a:r>
               <a:rPr i="1"/>
-              <a:t>qualitatively</a:t>
-            </a:r>
-            <a:r>
-              <a:rPr/>
-              <a:t> different — it shows the system can sometimes </a:t>
-            </a:r>
-            <a:r>
-              <a:rPr i="1"/>
-              <a:t>construct</a:t>
-            </a:r>
-            <a:r>
-              <a:rPr/>
-              <a:t> a correct answer rather than just </a:t>
-            </a:r>
-            <a:r>
-              <a:rPr i="1"/>
-              <a:t>select</a:t>
-            </a:r>
-            <a:r>
-              <a:rPr/>
-              <a:t> one. Rare (n=1) but a proof-of-possibility for compositional repair. If time allows, quote the judge rationale from dfadab01:1: “Some solvers assume a stamp must fit fully. Others assume stamps are clipped at the border…” — shows the judge reasoning about disagreement explicitly.</a:t>
+              <a:t>full reasoning traces</a:t>
+            </a:r>
+            <a:r>
+              <a:rPr/>
+              <a:t>, not just final answers — this is what enables minority recovery. Mention early-stop to pre-empt the obvious cost objection.</a:t>
             </a:r>
           </a:p>
         </p:txBody>
@@ -1727,35 +1947,7 @@
             </a:pPr>
             <a:r>
               <a:rPr/>
-              <a:t>This is the pedagogical heart of the talk. Don’t rush. Budget 2:30.</a:t>
-            </a:r>
-          </a:p>
-          <a:p>
-            <a:pPr lvl="0" indent="0" marL="0">
-              <a:buNone/>
-            </a:pPr>
-          </a:p>
-          <a:p>
-            <a:pPr lvl="0" indent="0" marL="0">
-              <a:buNone/>
-            </a:pPr>
-            <a:r>
-              <a:rPr/>
-              <a:t>Script: (0:30) Show the task; let the audience attempt it mentally. (0:30) Show what TEXT candidates produce — note the dominant (wrong) interpretation. (0:30) Show what IMAGE candidates produce — note where they diverge from Text. (0:30) Show what CODE candidates produce — note any structurally different hypothesis. (0:30) Reveal the judge’s reasoning: which cluster it rejected, which minority it elevated, why pass@2 lets it hedge.</a:t>
-            </a:r>
-          </a:p>
-          <a:p>
-            <a:pPr lvl="0" indent="0" marL="0">
-              <a:buNone/>
-            </a:pPr>
-          </a:p>
-          <a:p>
-            <a:pPr lvl="0" indent="0" marL="0">
-              <a:buNone/>
-            </a:pPr>
-            <a:r>
-              <a:rPr/>
-              <a:t>If tight on time, drop the IMAGE step and go Text → Code → Judge — the contrast is sharpest there. End with: “This is what ‘modalities as search operators’ looks like in practice.”</a:t>
+              <a:t>A success story. The submission got this task right: 28 of 29 candidates wrong, but the holistic judges identified the one correct image-prompt candidate. Four train pairs all reducing to a nested-frame output determined by the topology of the winding path. Selection layer recovered the rare correct one — what majority voting cannot do. One of the +7 minority recoveries from the holistic-judging ablation.</a:t>
             </a:r>
           </a:p>
         </p:txBody>
@@ -4810,7 +5002,7 @@
             </a:pPr>
             <a:r>
               <a:rPr/>
-              <a:t>72.9% on ARC Prize Verified — built on three frontier models, not one</a:t>
+              <a:t>72.9% verified result, beating frontier models by ~20%</a:t>
             </a:r>
             <a:br/>
             <a:br/>
@@ -4852,6 +5044,2836 @@
 </file>
 
 <file path=ppt/slides/slide10.xml><?xml version="1.0" encoding="utf-8"?>
+<p:sld xmlns:a="http://schemas.openxmlformats.org/drawingml/2006/main" xmlns:r="http://schemas.openxmlformats.org/officeDocument/2006/relationships" xmlns:p="http://schemas.openxmlformats.org/presentationml/2006/main">
+  <p:cSld>
+    <p:spTree>
+      <p:nvGrpSpPr>
+        <p:cNvPr id="1" name=""/>
+        <p:cNvGrpSpPr/>
+        <p:nvPr/>
+      </p:nvGrpSpPr>
+      <p:grpSpPr>
+        <a:xfrm>
+          <a:off x="0" y="0"/>
+          <a:ext cx="0" cy="0"/>
+          <a:chOff x="0" y="0"/>
+          <a:chExt cx="0" cy="0"/>
+        </a:xfrm>
+      </p:grpSpPr>
+      <p:sp>
+        <p:nvSpPr>
+          <p:cNvPr id="2" name="Title 1"/>
+          <p:cNvSpPr>
+            <a:spLocks noGrp="1"/>
+          </p:cNvSpPr>
+          <p:nvPr>
+            <p:ph type="title"/>
+          </p:nvPr>
+        </p:nvSpPr>
+        <p:spPr/>
+        <p:txBody>
+          <a:bodyPr/>
+          <a:lstStyle/>
+          <a:p>
+            <a:pPr lvl="0" indent="0" marL="0">
+              <a:buNone/>
+            </a:pPr>
+            <a:r>
+              <a:rPr/>
+              <a:t>(1) + (2) on a real task — 28 of 29 candidates wrong, judges picked the right one</a:t>
+            </a:r>
+          </a:p>
+        </p:txBody>
+      </p:sp>
+      <p:pic>
+        <p:nvPicPr>
+          <p:cNvPr descr="figures/task_2d0172a1.png" id="0" name="Picture 1"/>
+          <p:cNvPicPr>
+            <a:picLocks noGrp="1" noChangeAspect="1"/>
+          </p:cNvPicPr>
+          <p:nvPr/>
+        </p:nvPicPr>
+        <p:blipFill>
+          <a:blip r:embed="rId3"/>
+          <a:stretch>
+            <a:fillRect/>
+          </a:stretch>
+        </p:blipFill>
+        <p:spPr bwMode="auto">
+          <a:xfrm>
+            <a:off x="1841500" y="1625600"/>
+            <a:ext cx="1282700" cy="2959100"/>
+          </a:xfrm>
+          <a:prstGeom prst="rect">
+            <a:avLst/>
+          </a:prstGeom>
+          <a:noFill/>
+          <a:ln w="9525">
+            <a:noFill/>
+            <a:headEnd/>
+            <a:tailEnd/>
+          </a:ln>
+        </p:spPr>
+      </p:pic>
+      <p:sp>
+        <p:nvSpPr>
+          <p:cNvPr id="5" name="Text Placeholder 4"/>
+          <p:cNvSpPr>
+            <a:spLocks noGrp="1"/>
+          </p:cNvSpPr>
+          <p:nvPr>
+            <p:ph idx="3" sz="quarter" type="body"/>
+          </p:nvPr>
+        </p:nvSpPr>
+        <p:spPr/>
+        <p:txBody>
+          <a:bodyPr/>
+          <a:lstStyle/>
+          <a:p>
+            <a:pPr lvl="0" indent="0" marL="0">
+              <a:buNone/>
+            </a:pPr>
+            <a:r>
+              <a:rPr b="1"/>
+              <a:t>Public eval task </a:t>
+            </a:r>
+            <a:r>
+              <a:rPr b="1">
+                <a:latin typeface="Courier"/>
+              </a:rPr>
+              <a:t>2d0172a1:1</a:t>
+            </a:r>
+            <a:r>
+              <a:rPr/>
+              <a:t> — candidate pool </a:t>
+            </a:r>
+            <a:r>
+              <a:rPr i="1"/>
+              <a:t>n</a:t>
+            </a:r>
+            <a:r>
+              <a:rPr/>
+              <a:t> = 29</a:t>
+            </a:r>
+          </a:p>
+        </p:txBody>
+      </p:sp>
+      <p:graphicFrame>
+        <p:nvGraphicFramePr>
+          <p:cNvPr id="6" name="Content Placeholder 5"/>
+          <p:cNvGraphicFramePr>
+            <a:graphicFrameLocks noGrp="1"/>
+          </p:cNvGraphicFramePr>
+          <p:nvPr>
+            <p:ph idx="1"/>
+          </p:nvPr>
+        </p:nvGraphicFramePr>
+        <p:xfrm>
+          <a:off x="4635500" y="1625600"/>
+          <a:ext cx="4038600" cy="2959100"/>
+        </p:xfrm>
+        <a:graphic>
+          <a:graphicData uri="http://schemas.openxmlformats.org/drawingml/2006/table">
+            <a:tbl>
+              <a:tblPr firstRow="1" bandRow="1">
+                <a:tableStyleId>{5C22544A-7EE6-4342-B048-85BDC9FD1C3A}</a:tableStyleId>
+              </a:tblPr>
+              <a:tblGrid>
+                <a:gridCol w="1346200"/>
+                <a:gridCol w="1346200"/>
+                <a:gridCol w="1346200"/>
+              </a:tblGrid>
+              <a:tr h="0">
+                <a:tc>
+                  <a:txBody>
+                    <a:bodyPr/>
+                    <a:lstStyle/>
+                    <a:p>
+                      <a:pPr lvl="0" indent="0" marL="0">
+                        <a:buNone/>
+                      </a:pPr>
+                      <a:r>
+                        <a:rPr/>
+                        <a:t>Modality family</a:t>
+                      </a:r>
+                    </a:p>
+                  </a:txBody>
+                  <a:tcPr/>
+                </a:tc>
+                <a:tc>
+                  <a:txBody>
+                    <a:bodyPr/>
+                    <a:lstStyle/>
+                    <a:p>
+                      <a:pPr lvl="0" indent="0" marL="0" algn="ctr">
+                        <a:buNone/>
+                      </a:pPr>
+                      <a:r>
+                        <a:rPr/>
+                        <a:t>Correct</a:t>
+                      </a:r>
+                    </a:p>
+                  </a:txBody>
+                  <a:tcPr/>
+                </a:tc>
+                <a:tc>
+                  <a:txBody>
+                    <a:bodyPr/>
+                    <a:lstStyle/>
+                    <a:p>
+                      <a:pPr lvl="0" indent="0" marL="0" algn="ctr">
+                        <a:buNone/>
+                      </a:pPr>
+                      <a:r>
+                        <a:rPr/>
+                        <a:t>Wrong</a:t>
+                      </a:r>
+                    </a:p>
+                  </a:txBody>
+                  <a:tcPr/>
+                </a:tc>
+              </a:tr>
+              <a:tr h="0">
+                <a:tc>
+                  <a:txBody>
+                    <a:bodyPr/>
+                    <a:lstStyle/>
+                    <a:p>
+                      <a:pPr lvl="0" indent="0" marL="0">
+                        <a:buNone/>
+                      </a:pPr>
+                      <a:r>
+                        <a:rPr/>
+                        <a:t>Text (8)</a:t>
+                      </a:r>
+                    </a:p>
+                  </a:txBody>
+                </a:tc>
+                <a:tc>
+                  <a:txBody>
+                    <a:bodyPr/>
+                    <a:lstStyle/>
+                    <a:p>
+                      <a:pPr lvl="0" indent="0" marL="0" algn="ctr">
+                        <a:buNone/>
+                      </a:pPr>
+                      <a:r>
+                        <a:rPr/>
+                        <a:t>0</a:t>
+                      </a:r>
+                    </a:p>
+                  </a:txBody>
+                </a:tc>
+                <a:tc>
+                  <a:txBody>
+                    <a:bodyPr/>
+                    <a:lstStyle/>
+                    <a:p>
+                      <a:pPr lvl="0" indent="0" marL="0" algn="ctr">
+                        <a:buNone/>
+                      </a:pPr>
+                      <a:r>
+                        <a:rPr/>
+                        <a:t>8</a:t>
+                      </a:r>
+                    </a:p>
+                  </a:txBody>
+                </a:tc>
+              </a:tr>
+              <a:tr h="0">
+                <a:tc>
+                  <a:txBody>
+                    <a:bodyPr/>
+                    <a:lstStyle/>
+                    <a:p>
+                      <a:pPr lvl="0" indent="0" marL="0">
+                        <a:buNone/>
+                      </a:pPr>
+                      <a:r>
+                        <a:rPr/>
+                        <a:t>Image (10)</a:t>
+                      </a:r>
+                    </a:p>
+                  </a:txBody>
+                </a:tc>
+                <a:tc>
+                  <a:txBody>
+                    <a:bodyPr/>
+                    <a:lstStyle/>
+                    <a:p>
+                      <a:pPr lvl="0" indent="0" marL="0" algn="ctr">
+                        <a:buNone/>
+                      </a:pPr>
+                      <a:r>
+                        <a:rPr b="1"/>
+                        <a:t>1</a:t>
+                      </a:r>
+                    </a:p>
+                  </a:txBody>
+                </a:tc>
+                <a:tc>
+                  <a:txBody>
+                    <a:bodyPr/>
+                    <a:lstStyle/>
+                    <a:p>
+                      <a:pPr lvl="0" indent="0" marL="0" algn="ctr">
+                        <a:buNone/>
+                      </a:pPr>
+                      <a:r>
+                        <a:rPr/>
+                        <a:t>9</a:t>
+                      </a:r>
+                    </a:p>
+                  </a:txBody>
+                </a:tc>
+              </a:tr>
+              <a:tr h="0">
+                <a:tc>
+                  <a:txBody>
+                    <a:bodyPr/>
+                    <a:lstStyle/>
+                    <a:p>
+                      <a:pPr lvl="0" indent="0" marL="0">
+                        <a:buNone/>
+                      </a:pPr>
+                      <a:r>
+                        <a:rPr/>
+                        <a:t>Code (11)</a:t>
+                      </a:r>
+                    </a:p>
+                  </a:txBody>
+                </a:tc>
+                <a:tc>
+                  <a:txBody>
+                    <a:bodyPr/>
+                    <a:lstStyle/>
+                    <a:p>
+                      <a:pPr lvl="0" indent="0" marL="0" algn="ctr">
+                        <a:buNone/>
+                      </a:pPr>
+                      <a:r>
+                        <a:rPr/>
+                        <a:t>0</a:t>
+                      </a:r>
+                    </a:p>
+                  </a:txBody>
+                </a:tc>
+                <a:tc>
+                  <a:txBody>
+                    <a:bodyPr/>
+                    <a:lstStyle/>
+                    <a:p>
+                      <a:pPr lvl="0" indent="0" marL="0" algn="ctr">
+                        <a:buNone/>
+                      </a:pPr>
+                      <a:r>
+                        <a:rPr/>
+                        <a:t>11</a:t>
+                      </a:r>
+                    </a:p>
+                  </a:txBody>
+                </a:tc>
+              </a:tr>
+              <a:tr h="0">
+                <a:tc>
+                  <a:txBody>
+                    <a:bodyPr/>
+                    <a:lstStyle/>
+                    <a:p>
+                      <a:pPr lvl="0" indent="0" marL="0">
+                        <a:buNone/>
+                      </a:pPr>
+                      <a:r>
+                        <a:rPr b="1"/>
+                        <a:t>Total</a:t>
+                      </a:r>
+                    </a:p>
+                  </a:txBody>
+                </a:tc>
+                <a:tc>
+                  <a:txBody>
+                    <a:bodyPr/>
+                    <a:lstStyle/>
+                    <a:p>
+                      <a:pPr lvl="0" indent="0" marL="0" algn="ctr">
+                        <a:buNone/>
+                      </a:pPr>
+                      <a:r>
+                        <a:rPr b="1"/>
+                        <a:t>1</a:t>
+                      </a:r>
+                    </a:p>
+                  </a:txBody>
+                </a:tc>
+                <a:tc>
+                  <a:txBody>
+                    <a:bodyPr/>
+                    <a:lstStyle/>
+                    <a:p>
+                      <a:pPr lvl="0" indent="0" marL="0" algn="ctr">
+                        <a:buNone/>
+                      </a:pPr>
+                      <a:r>
+                        <a:rPr b="1"/>
+                        <a:t>28</a:t>
+                      </a:r>
+                    </a:p>
+                  </a:txBody>
+                </a:tc>
+              </a:tr>
+            </a:tbl>
+          </a:graphicData>
+        </a:graphic>
+      </p:graphicFrame>
+      <p:sp>
+        <p:nvSpPr>
+          <p:cNvPr id="6" name="Content Placeholder 5"/>
+          <p:cNvSpPr>
+            <a:spLocks noGrp="1"/>
+          </p:cNvSpPr>
+          <p:nvPr>
+            <p:ph idx="4" sz="quarter"/>
+          </p:nvPr>
+        </p:nvSpPr>
+        <p:spPr/>
+        <p:txBody>
+          <a:bodyPr/>
+          <a:lstStyle/>
+          <a:p>
+            <a:pPr lvl="0" indent="0" marL="1270000">
+              <a:buNone/>
+            </a:pPr>
+            <a:r>
+              <a:rPr sz="2000"/>
+              <a:t>✅ </a:t>
+            </a:r>
+            <a:r>
+              <a:rPr sz="2000" b="1"/>
+              <a:t>Submission verdict: SOLVED</a:t>
+            </a:r>
+            <a:r>
+              <a:rPr sz="2000"/>
+              <a:t> — the holistic judges selected the lone correct candidate.</a:t>
+            </a:r>
+          </a:p>
+          <a:p>
+            <a:pPr lvl="0"/>
+            <a:r>
+              <a:rPr/>
+              <a:t>One image candidate produced the correct nested-frame output; 28 of 29 candidates were wrong</a:t>
+            </a:r>
+          </a:p>
+          <a:p>
+            <a:pPr lvl="0"/>
+            <a:r>
+              <a:rPr/>
+              <a:t>Majority voting would collapse onto the wrong cluster</a:t>
+            </a:r>
+          </a:p>
+          <a:p>
+            <a:pPr lvl="0"/>
+            <a:r>
+              <a:rPr b="1"/>
+              <a:t>Our judges recovered the minority-correct candidate — that’s what the submission scored on</a:t>
+            </a:r>
+          </a:p>
+        </p:txBody>
+      </p:sp>
+    </p:spTree>
+  </p:cSld>
+</p:sld>
+</file>
+
+<file path=ppt/slides/slide11.xml><?xml version="1.0" encoding="utf-8"?>
+<p:sld xmlns:a="http://schemas.openxmlformats.org/drawingml/2006/main" xmlns:r="http://schemas.openxmlformats.org/officeDocument/2006/relationships" xmlns:p="http://schemas.openxmlformats.org/presentationml/2006/main">
+  <p:cSld>
+    <p:spTree>
+      <p:nvGrpSpPr>
+        <p:cNvPr id="1" name=""/>
+        <p:cNvGrpSpPr/>
+        <p:nvPr/>
+      </p:nvGrpSpPr>
+      <p:grpSpPr>
+        <a:xfrm>
+          <a:off x="0" y="0"/>
+          <a:ext cx="0" cy="0"/>
+          <a:chOff x="0" y="0"/>
+          <a:chExt cx="0" cy="0"/>
+        </a:xfrm>
+      </p:grpSpPr>
+      <p:sp>
+        <p:nvSpPr>
+          <p:cNvPr id="2" name="Title 1"/>
+          <p:cNvSpPr>
+            <a:spLocks noGrp="1"/>
+          </p:cNvSpPr>
+          <p:nvPr>
+            <p:ph type="title"/>
+          </p:nvPr>
+        </p:nvSpPr>
+        <p:spPr/>
+        <p:txBody>
+          <a:bodyPr/>
+          <a:lstStyle/>
+          <a:p>
+            <a:pPr lvl="0" indent="0" marL="0">
+              <a:buNone/>
+            </a:pPr>
+            <a:r>
+              <a:rPr/>
+              <a:t>(2) Recognize the rare-correct — what the judges actually read (</a:t>
+            </a:r>
+            <a:r>
+              <a:rPr>
+                <a:latin typeface="Courier"/>
+              </a:rPr>
+              <a:t>2d0172a1:1</a:t>
+            </a:r>
+            <a:r>
+              <a:rPr/>
+              <a:t>)</a:t>
+            </a:r>
+          </a:p>
+        </p:txBody>
+      </p:sp>
+      <p:sp>
+        <p:nvSpPr>
+          <p:cNvPr id="3" name="Content Placeholder 2"/>
+          <p:cNvSpPr>
+            <a:spLocks noGrp="1"/>
+          </p:cNvSpPr>
+          <p:nvPr>
+            <p:ph idx="1"/>
+          </p:nvPr>
+        </p:nvSpPr>
+        <p:spPr/>
+        <p:txBody>
+          <a:bodyPr/>
+          <a:lstStyle/>
+          <a:p>
+            <a:pPr lvl="0" indent="0" marL="0">
+              <a:buNone/>
+            </a:pPr>
+            <a:r>
+              <a:rPr/>
+              <a:t>This task produced </a:t>
+            </a:r>
+            <a:r>
+              <a:rPr b="1"/>
+              <a:t>31,208 lines</a:t>
+            </a:r>
+            <a:r>
+              <a:rPr/>
+              <a:t> of reasoning traces / logs.</a:t>
+            </a:r>
+          </a:p>
+        </p:txBody>
+      </p:sp>
+    </p:spTree>
+  </p:cSld>
+</p:sld>
+</file>
+
+<file path=ppt/slides/slide12.xml><?xml version="1.0" encoding="utf-8"?>
+<p:sld xmlns:a="http://schemas.openxmlformats.org/drawingml/2006/main" xmlns:r="http://schemas.openxmlformats.org/officeDocument/2006/relationships" xmlns:p="http://schemas.openxmlformats.org/presentationml/2006/main">
+  <p:cSld>
+    <p:spTree>
+      <p:nvGrpSpPr>
+        <p:cNvPr id="1" name=""/>
+        <p:cNvGrpSpPr/>
+        <p:nvPr/>
+      </p:nvGrpSpPr>
+      <p:grpSpPr>
+        <a:xfrm>
+          <a:off x="0" y="0"/>
+          <a:ext cx="0" cy="0"/>
+          <a:chOff x="0" y="0"/>
+          <a:chExt cx="0" cy="0"/>
+        </a:xfrm>
+      </p:grpSpPr>
+      <p:sp>
+        <p:nvSpPr>
+          <p:cNvPr id="3" name="Content Placeholder 2"/>
+          <p:cNvSpPr>
+            <a:spLocks noGrp="1"/>
+          </p:cNvSpPr>
+          <p:nvPr>
+            <p:ph idx="1" sz="half"/>
+          </p:nvPr>
+        </p:nvSpPr>
+        <p:spPr/>
+        <p:txBody>
+          <a:bodyPr/>
+          <a:lstStyle/>
+          <a:p>
+            <a:pPr lvl="0" indent="0" marL="0">
+              <a:buNone/>
+            </a:pPr>
+            <a:r>
+              <a:rPr b="1"/>
+              <a:t>Winning candidate</a:t>
+            </a:r>
+            <a:r>
+              <a:rPr/>
+              <a:t> — GPT-5.2 x-high, image modality</a:t>
+            </a:r>
+          </a:p>
+          <a:p>
+            <a:pPr lvl="0" indent="0">
+              <a:buNone/>
+            </a:pPr>
+            <a:r>
+              <a:rPr b="1">
+                <a:solidFill>
+                  <a:srgbClr val="FF0000"/>
+                </a:solidFill>
+                <a:latin typeface="Courier"/>
+              </a:rPr>
+              <a:t>//</a:t>
+            </a:r>
+            <a:r>
+              <a:rPr>
+                <a:latin typeface="Courier"/>
+              </a:rPr>
+              <a:t> </a:t>
+            </a:r>
+            <a:r>
+              <a:rPr b="1">
+                <a:solidFill>
+                  <a:srgbClr val="FF0000"/>
+                </a:solidFill>
+                <a:latin typeface="Courier"/>
+              </a:rPr>
+              <a:t>logs/</a:t>
+            </a:r>
+            <a:r>
+              <a:rPr>
+                <a:solidFill>
+                  <a:srgbClr val="40A070"/>
+                </a:solidFill>
+                <a:latin typeface="Courier"/>
+              </a:rPr>
+              <a:t>2026</a:t>
+            </a:r>
+            <a:r>
+              <a:rPr b="1">
+                <a:solidFill>
+                  <a:srgbClr val="FF0000"/>
+                </a:solidFill>
+                <a:latin typeface="Courier"/>
+              </a:rPr>
+              <a:t>-01-04_</a:t>
+            </a:r>
+            <a:r>
+              <a:rPr>
+                <a:solidFill>
+                  <a:srgbClr val="40A070"/>
+                </a:solidFill>
+                <a:latin typeface="Courier"/>
+              </a:rPr>
+              <a:t>22</a:t>
+            </a:r>
+            <a:r>
+              <a:rPr b="1">
+                <a:solidFill>
+                  <a:srgbClr val="FF0000"/>
+                </a:solidFill>
+                <a:latin typeface="Courier"/>
+              </a:rPr>
+              <a:t>-09</a:t>
+            </a:r>
+            <a:r>
+              <a:rPr>
+                <a:solidFill>
+                  <a:srgbClr val="40A070"/>
+                </a:solidFill>
+                <a:latin typeface="Courier"/>
+              </a:rPr>
+              <a:t>-54</a:t>
+            </a:r>
+            <a:r>
+              <a:rPr b="1">
+                <a:solidFill>
+                  <a:srgbClr val="FF0000"/>
+                </a:solidFill>
+                <a:latin typeface="Courier"/>
+              </a:rPr>
+              <a:t>_</a:t>
+            </a:r>
+            <a:r>
+              <a:rPr>
+                <a:solidFill>
+                  <a:srgbClr val="40A070"/>
+                </a:solidFill>
+                <a:latin typeface="Courier"/>
+              </a:rPr>
+              <a:t>2</a:t>
+            </a:r>
+            <a:r>
+              <a:rPr b="1">
+                <a:solidFill>
+                  <a:srgbClr val="FF0000"/>
+                </a:solidFill>
+                <a:latin typeface="Courier"/>
+              </a:rPr>
+              <a:t>d0172a1_</a:t>
+            </a:r>
+            <a:r>
+              <a:rPr>
+                <a:solidFill>
+                  <a:srgbClr val="40A070"/>
+                </a:solidFill>
+                <a:latin typeface="Courier"/>
+              </a:rPr>
+              <a:t>1</a:t>
+            </a:r>
+            <a:r>
+              <a:rPr b="1">
+                <a:solidFill>
+                  <a:srgbClr val="FF0000"/>
+                </a:solidFill>
+                <a:latin typeface="Courier"/>
+              </a:rPr>
+              <a:t>_step_</a:t>
+            </a:r>
+            <a:r>
+              <a:rPr>
+                <a:solidFill>
+                  <a:srgbClr val="40A070"/>
+                </a:solidFill>
+                <a:latin typeface="Courier"/>
+              </a:rPr>
+              <a:t>5</a:t>
+            </a:r>
+            <a:r>
+              <a:rPr b="1">
+                <a:solidFill>
+                  <a:srgbClr val="FF0000"/>
+                </a:solidFill>
+                <a:latin typeface="Courier"/>
+              </a:rPr>
+              <a:t>.json</a:t>
+            </a:r>
+            <a:br/>
+            <a:r>
+              <a:rPr>
+                <a:solidFill>
+                  <a:srgbClr val="06287E"/>
+                </a:solidFill>
+                <a:latin typeface="Courier"/>
+              </a:rPr>
+              <a:t>{</a:t>
+            </a:r>
+            <a:br/>
+            <a:r>
+              <a:rPr>
+                <a:latin typeface="Courier"/>
+              </a:rPr>
+              <a:t>  </a:t>
+            </a:r>
+            <a:r>
+              <a:rPr>
+                <a:solidFill>
+                  <a:srgbClr val="902000"/>
+                </a:solidFill>
+                <a:latin typeface="Courier"/>
+              </a:rPr>
+              <a:t>"image"</a:t>
+            </a:r>
+            <a:r>
+              <a:rPr>
+                <a:solidFill>
+                  <a:srgbClr val="06287E"/>
+                </a:solidFill>
+                <a:latin typeface="Courier"/>
+              </a:rPr>
+              <a:t>:</a:t>
+            </a:r>
+            <a:r>
+              <a:rPr>
+                <a:latin typeface="Courier"/>
+              </a:rPr>
+              <a:t> </a:t>
+            </a:r>
+            <a:r>
+              <a:rPr>
+                <a:solidFill>
+                  <a:srgbClr val="06287E"/>
+                </a:solidFill>
+                <a:latin typeface="Courier"/>
+              </a:rPr>
+              <a:t>{</a:t>
+            </a:r>
+            <a:br/>
+            <a:r>
+              <a:rPr>
+                <a:latin typeface="Courier"/>
+              </a:rPr>
+              <a:t>    </a:t>
+            </a:r>
+            <a:r>
+              <a:rPr b="1">
+                <a:solidFill>
+                  <a:srgbClr val="FF0000"/>
+                </a:solidFill>
+                <a:latin typeface="Courier"/>
+              </a:rPr>
+              <a:t>...</a:t>
+            </a:r>
+            <a:br/>
+            <a:r>
+              <a:rPr>
+                <a:latin typeface="Courier"/>
+              </a:rPr>
+              <a:t>    </a:t>
+            </a:r>
+            <a:r>
+              <a:rPr>
+                <a:solidFill>
+                  <a:srgbClr val="902000"/>
+                </a:solidFill>
+                <a:latin typeface="Courier"/>
+              </a:rPr>
+              <a:t>"gpt-5.2-xhigh_13_step_5_image_..."</a:t>
+            </a:r>
+            <a:r>
+              <a:rPr>
+                <a:solidFill>
+                  <a:srgbClr val="06287E"/>
+                </a:solidFill>
+                <a:latin typeface="Courier"/>
+              </a:rPr>
+              <a:t>:</a:t>
+            </a:r>
+            <a:r>
+              <a:rPr>
+                <a:latin typeface="Courier"/>
+              </a:rPr>
+              <a:t> </a:t>
+            </a:r>
+            <a:r>
+              <a:rPr>
+                <a:solidFill>
+                  <a:srgbClr val="06287E"/>
+                </a:solidFill>
+                <a:latin typeface="Courier"/>
+              </a:rPr>
+              <a:t>{</a:t>
+            </a:r>
+            <a:br/>
+            <a:r>
+              <a:rPr>
+                <a:latin typeface="Courier"/>
+              </a:rPr>
+              <a:t>      </a:t>
+            </a:r>
+            <a:r>
+              <a:rPr>
+                <a:solidFill>
+                  <a:srgbClr val="902000"/>
+                </a:solidFill>
+                <a:latin typeface="Courier"/>
+              </a:rPr>
+              <a:t>"actual_model"</a:t>
+            </a:r>
+            <a:r>
+              <a:rPr>
+                <a:solidFill>
+                  <a:srgbClr val="06287E"/>
+                </a:solidFill>
+                <a:latin typeface="Courier"/>
+              </a:rPr>
+              <a:t>:</a:t>
+            </a:r>
+            <a:r>
+              <a:rPr>
+                <a:latin typeface="Courier"/>
+              </a:rPr>
+              <a:t> </a:t>
+            </a:r>
+            <a:r>
+              <a:rPr>
+                <a:solidFill>
+                  <a:srgbClr val="4070A0"/>
+                </a:solidFill>
+                <a:latin typeface="Courier"/>
+              </a:rPr>
+              <a:t>"gpt-5.2-xhigh"</a:t>
+            </a:r>
+            <a:r>
+              <a:rPr>
+                <a:solidFill>
+                  <a:srgbClr val="06287E"/>
+                </a:solidFill>
+                <a:latin typeface="Courier"/>
+              </a:rPr>
+              <a:t>,</a:t>
+            </a:r>
+            <a:br/>
+            <a:r>
+              <a:rPr>
+                <a:latin typeface="Courier"/>
+              </a:rPr>
+              <a:t>      </a:t>
+            </a:r>
+            <a:r>
+              <a:rPr>
+                <a:solidFill>
+                  <a:srgbClr val="902000"/>
+                </a:solidFill>
+                <a:latin typeface="Courier"/>
+              </a:rPr>
+              <a:t>"input_tokens"</a:t>
+            </a:r>
+            <a:r>
+              <a:rPr>
+                <a:solidFill>
+                  <a:srgbClr val="06287E"/>
+                </a:solidFill>
+                <a:latin typeface="Courier"/>
+              </a:rPr>
+              <a:t>:</a:t>
+            </a:r>
+            <a:r>
+              <a:rPr>
+                <a:latin typeface="Courier"/>
+              </a:rPr>
+              <a:t> </a:t>
+            </a:r>
+            <a:r>
+              <a:rPr>
+                <a:solidFill>
+                  <a:srgbClr val="40A070"/>
+                </a:solidFill>
+                <a:latin typeface="Courier"/>
+              </a:rPr>
+              <a:t>21188</a:t>
+            </a:r>
+            <a:r>
+              <a:rPr>
+                <a:solidFill>
+                  <a:srgbClr val="06287E"/>
+                </a:solidFill>
+                <a:latin typeface="Courier"/>
+              </a:rPr>
+              <a:t>,</a:t>
+            </a:r>
+            <a:br/>
+            <a:r>
+              <a:rPr>
+                <a:latin typeface="Courier"/>
+              </a:rPr>
+              <a:t>      </a:t>
+            </a:r>
+            <a:r>
+              <a:rPr>
+                <a:solidFill>
+                  <a:srgbClr val="902000"/>
+                </a:solidFill>
+                <a:latin typeface="Courier"/>
+              </a:rPr>
+              <a:t>"output_tokens"</a:t>
+            </a:r>
+            <a:r>
+              <a:rPr>
+                <a:solidFill>
+                  <a:srgbClr val="06287E"/>
+                </a:solidFill>
+                <a:latin typeface="Courier"/>
+              </a:rPr>
+              <a:t>:</a:t>
+            </a:r>
+            <a:r>
+              <a:rPr>
+                <a:latin typeface="Courier"/>
+              </a:rPr>
+              <a:t> </a:t>
+            </a:r>
+            <a:r>
+              <a:rPr>
+                <a:solidFill>
+                  <a:srgbClr val="40A070"/>
+                </a:solidFill>
+                <a:latin typeface="Courier"/>
+              </a:rPr>
+              <a:t>59323</a:t>
+            </a:r>
+            <a:r>
+              <a:rPr>
+                <a:solidFill>
+                  <a:srgbClr val="06287E"/>
+                </a:solidFill>
+                <a:latin typeface="Courier"/>
+              </a:rPr>
+              <a:t>,</a:t>
+            </a:r>
+            <a:br/>
+            <a:r>
+              <a:rPr>
+                <a:latin typeface="Courier"/>
+              </a:rPr>
+              <a:t>      </a:t>
+            </a:r>
+            <a:r>
+              <a:rPr>
+                <a:solidFill>
+                  <a:srgbClr val="902000"/>
+                </a:solidFill>
+                <a:latin typeface="Courier"/>
+              </a:rPr>
+              <a:t>"Full raw LLM response"</a:t>
+            </a:r>
+            <a:r>
+              <a:rPr>
+                <a:solidFill>
+                  <a:srgbClr val="06287E"/>
+                </a:solidFill>
+                <a:latin typeface="Courier"/>
+              </a:rPr>
+              <a:t>:</a:t>
+            </a:r>
+            <a:br/>
+            <a:r>
+              <a:rPr>
+                <a:solidFill>
+                  <a:srgbClr val="4070A0"/>
+                </a:solidFill>
+                <a:latin typeface="Courier"/>
+              </a:rPr>
+              <a:t>"### What the examples show</a:t>
+            </a:r>
+            <a:br/>
+            <a:br/>
+            <a:r>
+              <a:rPr>
+                <a:solidFill>
+                  <a:srgbClr val="4070A0"/>
+                </a:solidFill>
+                <a:latin typeface="Courier"/>
+              </a:rPr>
+              <a:t>In every example, the foreground pixels form</a:t>
+            </a:r>
+            <a:br/>
+            <a:r>
+              <a:rPr>
+                <a:solidFill>
+                  <a:srgbClr val="4070A0"/>
+                </a:solidFill>
+                <a:latin typeface="Courier"/>
+              </a:rPr>
+              <a:t>several **separate components** of two types:</a:t>
+            </a:r>
+            <a:br/>
+            <a:br/>
+            <a:r>
+              <a:rPr>
+                <a:solidFill>
+                  <a:srgbClr val="4070A0"/>
+                </a:solidFill>
+                <a:latin typeface="Courier"/>
+              </a:rPr>
+              <a:t>1. **Frames (loops):** ... every such component</a:t>
+            </a:r>
+            <a:br/>
+            <a:r>
+              <a:rPr>
+                <a:solidFill>
+                  <a:srgbClr val="4070A0"/>
+                </a:solidFill>
+                <a:latin typeface="Courier"/>
+              </a:rPr>
+              <a:t>   becomes a **perfect axis-aligned rectangular</a:t>
+            </a:r>
+            <a:br/>
+            <a:r>
+              <a:rPr>
+                <a:solidFill>
+                  <a:srgbClr val="4070A0"/>
+                </a:solidFill>
+                <a:latin typeface="Courier"/>
+              </a:rPr>
+              <a:t>   border** (thickness 1).</a:t>
+            </a:r>
+            <a:br/>
+            <a:r>
+              <a:rPr>
+                <a:solidFill>
+                  <a:srgbClr val="4070A0"/>
+                </a:solidFill>
+                <a:latin typeface="Courier"/>
+              </a:rPr>
+              <a:t>2. **Markers (solid small components):** ...</a:t>
+            </a:r>
+            <a:br/>
+            <a:r>
+              <a:rPr>
+                <a:solidFill>
+                  <a:srgbClr val="4070A0"/>
+                </a:solidFill>
+                <a:latin typeface="Courier"/>
+              </a:rPr>
+              <a:t>   each marker is reduced to a **single</a:t>
+            </a:r>
+            <a:br/>
+            <a:r>
+              <a:rPr>
+                <a:solidFill>
+                  <a:srgbClr val="4070A0"/>
+                </a:solidFill>
+                <a:latin typeface="Courier"/>
+              </a:rPr>
+              <a:t>   foreground cell**.</a:t>
+            </a:r>
+            <a:br/>
+            <a:r>
+              <a:rPr>
+                <a:solidFill>
+                  <a:srgbClr val="4070A0"/>
+                </a:solidFill>
+                <a:latin typeface="Courier"/>
+              </a:rPr>
+              <a:t>...</a:t>
+            </a:r>
+            <a:br/>
+            <a:r>
+              <a:rPr>
+                <a:solidFill>
+                  <a:srgbClr val="4070A0"/>
+                </a:solidFill>
+                <a:latin typeface="Courier"/>
+              </a:rPr>
+              <a:t>### Applying to the test input</a:t>
+            </a:r>
+            <a:br/>
+            <a:r>
+              <a:rPr>
+                <a:solidFill>
+                  <a:srgbClr val="4070A0"/>
+                </a:solidFill>
+                <a:latin typeface="Courier"/>
+              </a:rPr>
+              <a:t>- Background color = **7**, foreground = **9**.</a:t>
+            </a:r>
+            <a:br/>
+            <a:r>
+              <a:rPr>
+                <a:solidFill>
+                  <a:srgbClr val="4070A0"/>
+                </a:solidFill>
+                <a:latin typeface="Courier"/>
+              </a:rPr>
+              <a:t>- One **outer loop frame**, one **inner loop</a:t>
+            </a:r>
+            <a:br/>
+            <a:r>
+              <a:rPr>
+                <a:solidFill>
+                  <a:srgbClr val="4070A0"/>
+                </a:solidFill>
+                <a:latin typeface="Courier"/>
+              </a:rPr>
+              <a:t>  frame** inside it, ... two **markers**</a:t>
+            </a:r>
+            <a:br/>
+            <a:r>
+              <a:rPr>
+                <a:solidFill>
+                  <a:srgbClr val="4070A0"/>
+                </a:solidFill>
+                <a:latin typeface="Courier"/>
+              </a:rPr>
+              <a:t>  inside, side-by-side ⇒ **horizontal**.</a:t>
+            </a:r>
+            <a:br/>
+            <a:r>
+              <a:rPr>
+                <a:solidFill>
+                  <a:srgbClr val="4070A0"/>
+                </a:solidFill>
+                <a:latin typeface="Courier"/>
+              </a:rPr>
+              <a:t>... outer size **9 rows × 13 columns**."</a:t>
+            </a:r>
+            <a:r>
+              <a:rPr>
+                <a:solidFill>
+                  <a:srgbClr val="06287E"/>
+                </a:solidFill>
+                <a:latin typeface="Courier"/>
+              </a:rPr>
+              <a:t>,</a:t>
+            </a:r>
+            <a:br/>
+            <a:r>
+              <a:rPr>
+                <a:latin typeface="Courier"/>
+              </a:rPr>
+              <a:t>      </a:t>
+            </a:r>
+            <a:r>
+              <a:rPr>
+                <a:solidFill>
+                  <a:srgbClr val="902000"/>
+                </a:solidFill>
+                <a:latin typeface="Courier"/>
+              </a:rPr>
+              <a:t>"Extracted grid"</a:t>
+            </a:r>
+            <a:r>
+              <a:rPr>
+                <a:solidFill>
+                  <a:srgbClr val="06287E"/>
+                </a:solidFill>
+                <a:latin typeface="Courier"/>
+              </a:rPr>
+              <a:t>:</a:t>
+            </a:r>
+            <a:r>
+              <a:rPr>
+                <a:latin typeface="Courier"/>
+              </a:rPr>
+              <a:t> </a:t>
+            </a:r>
+            <a:r>
+              <a:rPr>
+                <a:solidFill>
+                  <a:srgbClr val="007020"/>
+                </a:solidFill>
+                <a:latin typeface="Courier"/>
+              </a:rPr>
+              <a:t>[</a:t>
+            </a:r>
+            <a:r>
+              <a:rPr b="1">
+                <a:solidFill>
+                  <a:srgbClr val="FF0000"/>
+                </a:solidFill>
+                <a:latin typeface="Courier"/>
+              </a:rPr>
+              <a:t>...</a:t>
+            </a:r>
+            <a:r>
+              <a:rPr>
+                <a:solidFill>
+                  <a:srgbClr val="007020"/>
+                </a:solidFill>
+                <a:latin typeface="Courier"/>
+              </a:rPr>
+              <a:t>]</a:t>
+            </a:r>
+            <a:br/>
+            <a:r>
+              <a:rPr>
+                <a:latin typeface="Courier"/>
+              </a:rPr>
+              <a:t>    </a:t>
+            </a:r>
+            <a:r>
+              <a:rPr>
+                <a:solidFill>
+                  <a:srgbClr val="06287E"/>
+                </a:solidFill>
+                <a:latin typeface="Courier"/>
+              </a:rPr>
+              <a:t>},</a:t>
+            </a:r>
+            <a:r>
+              <a:rPr>
+                <a:latin typeface="Courier"/>
+              </a:rPr>
+              <a:t> </a:t>
+            </a:r>
+            <a:r>
+              <a:rPr b="1">
+                <a:solidFill>
+                  <a:srgbClr val="FF0000"/>
+                </a:solidFill>
+                <a:latin typeface="Courier"/>
+              </a:rPr>
+              <a:t>...</a:t>
+            </a:r>
+            <a:br/>
+            <a:r>
+              <a:rPr>
+                <a:latin typeface="Courier"/>
+              </a:rPr>
+              <a:t>  </a:t>
+            </a:r>
+            <a:r>
+              <a:rPr>
+                <a:solidFill>
+                  <a:srgbClr val="06287E"/>
+                </a:solidFill>
+                <a:latin typeface="Courier"/>
+              </a:rPr>
+              <a:t>},</a:t>
+            </a:r>
+            <a:r>
+              <a:rPr>
+                <a:latin typeface="Courier"/>
+              </a:rPr>
+              <a:t> </a:t>
+            </a:r>
+            <a:r>
+              <a:rPr b="1">
+                <a:solidFill>
+                  <a:srgbClr val="FF0000"/>
+                </a:solidFill>
+                <a:latin typeface="Courier"/>
+              </a:rPr>
+              <a:t>...</a:t>
+            </a:r>
+            <a:br/>
+            <a:r>
+              <a:rPr>
+                <a:solidFill>
+                  <a:srgbClr val="06287E"/>
+                </a:solidFill>
+                <a:latin typeface="Courier"/>
+              </a:rPr>
+              <a:t>}</a:t>
+            </a:r>
+          </a:p>
+        </p:txBody>
+      </p:sp>
+      <p:sp>
+        <p:nvSpPr>
+          <p:cNvPr id="4" name="Content Placeholder 3"/>
+          <p:cNvSpPr>
+            <a:spLocks noGrp="1"/>
+          </p:cNvSpPr>
+          <p:nvPr>
+            <p:ph idx="2" sz="half"/>
+          </p:nvPr>
+        </p:nvSpPr>
+        <p:spPr/>
+        <p:txBody>
+          <a:bodyPr/>
+          <a:lstStyle/>
+          <a:p>
+            <a:pPr lvl="0" indent="0" marL="0">
+              <a:buNone/>
+            </a:pPr>
+            <a:r>
+              <a:rPr b="1"/>
+              <a:t>Judge’s selection rationale</a:t>
+            </a:r>
+            <a:r>
+              <a:rPr/>
+              <a:t> — GPT-5.2 x-high × 3; all 3 picked correctly</a:t>
+            </a:r>
+          </a:p>
+          <a:p>
+            <a:pPr lvl="0" indent="0">
+              <a:buNone/>
+            </a:pPr>
+            <a:r>
+              <a:rPr b="1">
+                <a:solidFill>
+                  <a:srgbClr val="FF0000"/>
+                </a:solidFill>
+                <a:latin typeface="Courier"/>
+              </a:rPr>
+              <a:t>//</a:t>
+            </a:r>
+            <a:r>
+              <a:rPr>
+                <a:latin typeface="Courier"/>
+              </a:rPr>
+              <a:t> </a:t>
+            </a:r>
+            <a:r>
+              <a:rPr b="1">
+                <a:solidFill>
+                  <a:srgbClr val="FF0000"/>
+                </a:solidFill>
+                <a:latin typeface="Courier"/>
+              </a:rPr>
+              <a:t>logs/</a:t>
+            </a:r>
+            <a:r>
+              <a:rPr>
+                <a:solidFill>
+                  <a:srgbClr val="40A070"/>
+                </a:solidFill>
+                <a:latin typeface="Courier"/>
+              </a:rPr>
+              <a:t>2026</a:t>
+            </a:r>
+            <a:r>
+              <a:rPr b="1">
+                <a:solidFill>
+                  <a:srgbClr val="FF0000"/>
+                </a:solidFill>
+                <a:latin typeface="Courier"/>
+              </a:rPr>
+              <a:t>-01-04_</a:t>
+            </a:r>
+            <a:r>
+              <a:rPr>
+                <a:solidFill>
+                  <a:srgbClr val="40A070"/>
+                </a:solidFill>
+                <a:latin typeface="Courier"/>
+              </a:rPr>
+              <a:t>22</a:t>
+            </a:r>
+            <a:r>
+              <a:rPr b="1">
+                <a:solidFill>
+                  <a:srgbClr val="FF0000"/>
+                </a:solidFill>
+                <a:latin typeface="Courier"/>
+              </a:rPr>
+              <a:t>-09</a:t>
+            </a:r>
+            <a:r>
+              <a:rPr>
+                <a:solidFill>
+                  <a:srgbClr val="40A070"/>
+                </a:solidFill>
+                <a:latin typeface="Courier"/>
+              </a:rPr>
+              <a:t>-54</a:t>
+            </a:r>
+            <a:r>
+              <a:rPr b="1">
+                <a:solidFill>
+                  <a:srgbClr val="FF0000"/>
+                </a:solidFill>
+                <a:latin typeface="Courier"/>
+              </a:rPr>
+              <a:t>_</a:t>
+            </a:r>
+            <a:r>
+              <a:rPr>
+                <a:solidFill>
+                  <a:srgbClr val="40A070"/>
+                </a:solidFill>
+                <a:latin typeface="Courier"/>
+              </a:rPr>
+              <a:t>2</a:t>
+            </a:r>
+            <a:r>
+              <a:rPr b="1">
+                <a:solidFill>
+                  <a:srgbClr val="FF0000"/>
+                </a:solidFill>
+                <a:latin typeface="Courier"/>
+              </a:rPr>
+              <a:t>d0172a1_</a:t>
+            </a:r>
+            <a:r>
+              <a:rPr>
+                <a:solidFill>
+                  <a:srgbClr val="40A070"/>
+                </a:solidFill>
+                <a:latin typeface="Courier"/>
+              </a:rPr>
+              <a:t>1</a:t>
+            </a:r>
+            <a:r>
+              <a:rPr b="1">
+                <a:solidFill>
+                  <a:srgbClr val="FF0000"/>
+                </a:solidFill>
+                <a:latin typeface="Courier"/>
+              </a:rPr>
+              <a:t>_step_finish.json</a:t>
+            </a:r>
+            <a:br/>
+            <a:r>
+              <a:rPr>
+                <a:solidFill>
+                  <a:srgbClr val="06287E"/>
+                </a:solidFill>
+                <a:latin typeface="Courier"/>
+              </a:rPr>
+              <a:t>{</a:t>
+            </a:r>
+            <a:br/>
+            <a:r>
+              <a:rPr>
+                <a:latin typeface="Courier"/>
+              </a:rPr>
+              <a:t>  </a:t>
+            </a:r>
+            <a:r>
+              <a:rPr b="1">
+                <a:solidFill>
+                  <a:srgbClr val="FF0000"/>
+                </a:solidFill>
+                <a:latin typeface="Courier"/>
+              </a:rPr>
+              <a:t>...</a:t>
+            </a:r>
+            <a:br/>
+            <a:r>
+              <a:rPr>
+                <a:latin typeface="Courier"/>
+              </a:rPr>
+              <a:t>  </a:t>
+            </a:r>
+            <a:r>
+              <a:rPr>
+                <a:solidFill>
+                  <a:srgbClr val="902000"/>
+                </a:solidFill>
+                <a:latin typeface="Courier"/>
+              </a:rPr>
+              <a:t>"selection_details"</a:t>
+            </a:r>
+            <a:r>
+              <a:rPr>
+                <a:solidFill>
+                  <a:srgbClr val="06287E"/>
+                </a:solidFill>
+                <a:latin typeface="Courier"/>
+              </a:rPr>
+              <a:t>:</a:t>
+            </a:r>
+            <a:r>
+              <a:rPr>
+                <a:latin typeface="Courier"/>
+              </a:rPr>
+              <a:t> </a:t>
+            </a:r>
+            <a:r>
+              <a:rPr>
+                <a:solidFill>
+                  <a:srgbClr val="06287E"/>
+                </a:solidFill>
+                <a:latin typeface="Courier"/>
+              </a:rPr>
+              <a:t>{</a:t>
+            </a:r>
+            <a:br/>
+            <a:r>
+              <a:rPr>
+                <a:latin typeface="Courier"/>
+              </a:rPr>
+              <a:t>    </a:t>
+            </a:r>
+            <a:r>
+              <a:rPr>
+                <a:solidFill>
+                  <a:srgbClr val="902000"/>
+                </a:solidFill>
+                <a:latin typeface="Courier"/>
+              </a:rPr>
+              <a:t>"judges"</a:t>
+            </a:r>
+            <a:r>
+              <a:rPr>
+                <a:solidFill>
+                  <a:srgbClr val="06287E"/>
+                </a:solidFill>
+                <a:latin typeface="Courier"/>
+              </a:rPr>
+              <a:t>:</a:t>
+            </a:r>
+            <a:r>
+              <a:rPr>
+                <a:latin typeface="Courier"/>
+              </a:rPr>
+              <a:t> </a:t>
+            </a:r>
+            <a:r>
+              <a:rPr>
+                <a:solidFill>
+                  <a:srgbClr val="06287E"/>
+                </a:solidFill>
+                <a:latin typeface="Courier"/>
+              </a:rPr>
+              <a:t>{</a:t>
+            </a:r>
+            <a:br/>
+            <a:r>
+              <a:rPr>
+                <a:latin typeface="Courier"/>
+              </a:rPr>
+              <a:t>      </a:t>
+            </a:r>
+            <a:r>
+              <a:rPr>
+                <a:solidFill>
+                  <a:srgbClr val="902000"/>
+                </a:solidFill>
+                <a:latin typeface="Courier"/>
+              </a:rPr>
+              <a:t>"duo_pick_council"</a:t>
+            </a:r>
+            <a:r>
+              <a:rPr>
+                <a:solidFill>
+                  <a:srgbClr val="06287E"/>
+                </a:solidFill>
+                <a:latin typeface="Courier"/>
+              </a:rPr>
+              <a:t>:</a:t>
+            </a:r>
+            <a:r>
+              <a:rPr>
+                <a:latin typeface="Courier"/>
+              </a:rPr>
+              <a:t> </a:t>
+            </a:r>
+            <a:r>
+              <a:rPr>
+                <a:solidFill>
+                  <a:srgbClr val="007020"/>
+                </a:solidFill>
+                <a:latin typeface="Courier"/>
+              </a:rPr>
+              <a:t>[</a:t>
+            </a:r>
+            <a:br/>
+            <a:r>
+              <a:rPr>
+                <a:latin typeface="Courier"/>
+              </a:rPr>
+              <a:t>        </a:t>
+            </a:r>
+            <a:r>
+              <a:rPr b="1">
+                <a:solidFill>
+                  <a:srgbClr val="FF0000"/>
+                </a:solidFill>
+                <a:latin typeface="Courier"/>
+              </a:rPr>
+              <a:t>...</a:t>
+            </a:r>
+            <a:r>
+              <a:rPr>
+                <a:solidFill>
+                  <a:srgbClr val="007020"/>
+                </a:solidFill>
+                <a:latin typeface="Courier"/>
+              </a:rPr>
+              <a:t>,</a:t>
+            </a:r>
+            <a:r>
+              <a:rPr>
+                <a:latin typeface="Courier"/>
+              </a:rPr>
+              <a:t> </a:t>
+            </a:r>
+            <a:r>
+              <a:rPr>
+                <a:solidFill>
+                  <a:srgbClr val="06287E"/>
+                </a:solidFill>
+                <a:latin typeface="Courier"/>
+              </a:rPr>
+              <a:t>{</a:t>
+            </a:r>
+            <a:br/>
+            <a:r>
+              <a:rPr>
+                <a:latin typeface="Courier"/>
+              </a:rPr>
+              <a:t>          </a:t>
+            </a:r>
+            <a:r>
+              <a:rPr>
+                <a:solidFill>
+                  <a:srgbClr val="902000"/>
+                </a:solidFill>
+                <a:latin typeface="Courier"/>
+              </a:rPr>
+              <a:t>"model"</a:t>
+            </a:r>
+            <a:r>
+              <a:rPr>
+                <a:solidFill>
+                  <a:srgbClr val="06287E"/>
+                </a:solidFill>
+                <a:latin typeface="Courier"/>
+              </a:rPr>
+              <a:t>:</a:t>
+            </a:r>
+            <a:r>
+              <a:rPr>
+                <a:latin typeface="Courier"/>
+              </a:rPr>
+              <a:t> </a:t>
+            </a:r>
+            <a:r>
+              <a:rPr>
+                <a:solidFill>
+                  <a:srgbClr val="4070A0"/>
+                </a:solidFill>
+                <a:latin typeface="Courier"/>
+              </a:rPr>
+              <a:t>"gpt-5.2-xhigh"</a:t>
+            </a:r>
+            <a:r>
+              <a:rPr>
+                <a:solidFill>
+                  <a:srgbClr val="06287E"/>
+                </a:solidFill>
+                <a:latin typeface="Courier"/>
+              </a:rPr>
+              <a:t>,</a:t>
+            </a:r>
+            <a:br/>
+            <a:r>
+              <a:rPr>
+                <a:latin typeface="Courier"/>
+              </a:rPr>
+              <a:t>          </a:t>
+            </a:r>
+            <a:r>
+              <a:rPr>
+                <a:solidFill>
+                  <a:srgbClr val="902000"/>
+                </a:solidFill>
+                <a:latin typeface="Courier"/>
+              </a:rPr>
+              <a:t>"response"</a:t>
+            </a:r>
+            <a:r>
+              <a:rPr>
+                <a:solidFill>
+                  <a:srgbClr val="06287E"/>
+                </a:solidFill>
+                <a:latin typeface="Courier"/>
+              </a:rPr>
+              <a:t>:</a:t>
+            </a:r>
+            <a:br/>
+            <a:r>
+              <a:rPr>
+                <a:solidFill>
+                  <a:srgbClr val="4070A0"/>
+                </a:solidFill>
+                <a:latin typeface="Courier"/>
+              </a:rPr>
+              <a:t>"Across the four solved examples, the</a:t>
+            </a:r>
+            <a:br/>
+            <a:r>
+              <a:rPr>
+                <a:solidFill>
+                  <a:srgbClr val="4070A0"/>
+                </a:solidFill>
+                <a:latin typeface="Courier"/>
+              </a:rPr>
+              <a:t>consistent mechanic is **topological</a:t>
+            </a:r>
+            <a:br/>
+            <a:r>
+              <a:rPr>
+                <a:solidFill>
+                  <a:srgbClr val="4070A0"/>
+                </a:solidFill>
+                <a:latin typeface="Courier"/>
+              </a:rPr>
+              <a:t>normalization**:</a:t>
+            </a:r>
+            <a:br/>
+            <a:r>
+              <a:rPr>
+                <a:solidFill>
+                  <a:srgbClr val="4070A0"/>
+                </a:solidFill>
+                <a:latin typeface="Courier"/>
+              </a:rPr>
+              <a:t>- Each **loop** becomes a **perfect 1-cell-</a:t>
+            </a:r>
+            <a:br/>
+            <a:r>
+              <a:rPr>
+                <a:solidFill>
+                  <a:srgbClr val="4070A0"/>
+                </a:solidFill>
+                <a:latin typeface="Courier"/>
+              </a:rPr>
+              <a:t>  thick rectangular frame**.</a:t>
+            </a:r>
+            <a:br/>
+            <a:r>
+              <a:rPr>
+                <a:solidFill>
+                  <a:srgbClr val="4070A0"/>
+                </a:solidFill>
+                <a:latin typeface="Courier"/>
+              </a:rPr>
+              <a:t>- Each **solid component** becomes a</a:t>
+            </a:r>
+            <a:br/>
+            <a:r>
+              <a:rPr>
+                <a:solidFill>
+                  <a:srgbClr val="4070A0"/>
+                </a:solidFill>
+                <a:latin typeface="Courier"/>
+              </a:rPr>
+              <a:t>  **single foreground cell (a dot)**.</a:t>
+            </a:r>
+            <a:br/>
+            <a:r>
+              <a:rPr>
+                <a:solidFill>
+                  <a:srgbClr val="4070A0"/>
+                </a:solidFill>
+                <a:latin typeface="Courier"/>
+              </a:rPr>
+              <a:t>...</a:t>
+            </a:r>
+            <a:br/>
+            <a:r>
+              <a:rPr>
+                <a:solidFill>
+                  <a:srgbClr val="4070A0"/>
+                </a:solidFill>
+                <a:latin typeface="Courier"/>
+              </a:rPr>
+              <a:t>The two that best match the examples *and*</a:t>
+            </a:r>
+            <a:br/>
+            <a:r>
+              <a:rPr>
+                <a:solidFill>
+                  <a:srgbClr val="4070A0"/>
+                </a:solidFill>
+                <a:latin typeface="Courier"/>
+              </a:rPr>
+              <a:t>the apparent test structure are:</a:t>
+            </a:r>
+            <a:br/>
+            <a:r>
+              <a:rPr>
+                <a:solidFill>
+                  <a:srgbClr val="4070A0"/>
+                </a:solidFill>
+                <a:latin typeface="Courier"/>
+              </a:rPr>
+              <a:t>- **Solution 10**: outer frame contains an</a:t>
+            </a:r>
+            <a:br/>
+            <a:r>
+              <a:rPr>
+                <a:solidFill>
+                  <a:srgbClr val="4070A0"/>
+                </a:solidFill>
+                <a:latin typeface="Courier"/>
+              </a:rPr>
+              <a:t>  inner frame **plus an extra dot to the</a:t>
+            </a:r>
+            <a:br/>
+            <a:r>
+              <a:rPr>
+                <a:solidFill>
+                  <a:srgbClr val="4070A0"/>
+                </a:solidFill>
+                <a:latin typeface="Courier"/>
+              </a:rPr>
+              <a:t>  right** (matching the extra small</a:t>
+            </a:r>
+            <a:br/>
+            <a:r>
+              <a:rPr>
+                <a:solidFill>
+                  <a:srgbClr val="4070A0"/>
+                </a:solidFill>
+                <a:latin typeface="Courier"/>
+              </a:rPr>
+              <a:t>  disconnected 9-component at cols ~20–21</a:t>
+            </a:r>
+            <a:br/>
+            <a:r>
+              <a:rPr>
+                <a:solidFill>
+                  <a:srgbClr val="4070A0"/>
+                </a:solidFill>
+                <a:latin typeface="Courier"/>
+              </a:rPr>
+              <a:t>  in the test input) ...</a:t>
+            </a:r>
+            <a:br/>
+            <a:r>
+              <a:rPr>
+                <a:solidFill>
+                  <a:srgbClr val="4070A0"/>
+                </a:solidFill>
+                <a:latin typeface="Courier"/>
+              </a:rPr>
+              <a:t>- **Solution 6/7**: the same, but **without**</a:t>
+            </a:r>
+            <a:br/>
+            <a:r>
+              <a:rPr>
+                <a:solidFill>
+                  <a:srgbClr val="4070A0"/>
+                </a:solidFill>
+                <a:latin typeface="Courier"/>
+              </a:rPr>
+              <a:t>  the extra right-side dot.</a:t>
+            </a:r>
+            <a:br/>
+            <a:r>
+              <a:rPr>
+                <a:solidFill>
+                  <a:srgbClr val="4070A0"/>
+                </a:solidFill>
+                <a:latin typeface="Courier"/>
+              </a:rPr>
+              <a:t>### Candidate 1 (most likely): Solution 10"</a:t>
+            </a:r>
+            <a:r>
+              <a:rPr>
+                <a:solidFill>
+                  <a:srgbClr val="06287E"/>
+                </a:solidFill>
+                <a:latin typeface="Courier"/>
+              </a:rPr>
+              <a:t>,</a:t>
+            </a:r>
+            <a:br/>
+            <a:r>
+              <a:rPr>
+                <a:latin typeface="Courier"/>
+              </a:rPr>
+              <a:t>          </a:t>
+            </a:r>
+            <a:r>
+              <a:rPr>
+                <a:solidFill>
+                  <a:srgbClr val="902000"/>
+                </a:solidFill>
+                <a:latin typeface="Courier"/>
+              </a:rPr>
+              <a:t>"picked_grids"</a:t>
+            </a:r>
+            <a:r>
+              <a:rPr>
+                <a:solidFill>
+                  <a:srgbClr val="06287E"/>
+                </a:solidFill>
+                <a:latin typeface="Courier"/>
+              </a:rPr>
+              <a:t>:</a:t>
+            </a:r>
+            <a:r>
+              <a:rPr>
+                <a:latin typeface="Courier"/>
+              </a:rPr>
+              <a:t> </a:t>
+            </a:r>
+            <a:r>
+              <a:rPr>
+                <a:solidFill>
+                  <a:srgbClr val="007020"/>
+                </a:solidFill>
+                <a:latin typeface="Courier"/>
+              </a:rPr>
+              <a:t>[</a:t>
+            </a:r>
+            <a:r>
+              <a:rPr b="1">
+                <a:solidFill>
+                  <a:srgbClr val="FF0000"/>
+                </a:solidFill>
+                <a:latin typeface="Courier"/>
+              </a:rPr>
+              <a:t>...</a:t>
+            </a:r>
+            <a:r>
+              <a:rPr>
+                <a:solidFill>
+                  <a:srgbClr val="007020"/>
+                </a:solidFill>
+                <a:latin typeface="Courier"/>
+              </a:rPr>
+              <a:t>]</a:t>
+            </a:r>
+            <a:br/>
+            <a:r>
+              <a:rPr>
+                <a:latin typeface="Courier"/>
+              </a:rPr>
+              <a:t>        </a:t>
+            </a:r>
+            <a:r>
+              <a:rPr>
+                <a:solidFill>
+                  <a:srgbClr val="06287E"/>
+                </a:solidFill>
+                <a:latin typeface="Courier"/>
+              </a:rPr>
+              <a:t>}</a:t>
+            </a:r>
+            <a:r>
+              <a:rPr>
+                <a:solidFill>
+                  <a:srgbClr val="007020"/>
+                </a:solidFill>
+                <a:latin typeface="Courier"/>
+              </a:rPr>
+              <a:t>,</a:t>
+            </a:r>
+            <a:r>
+              <a:rPr>
+                <a:latin typeface="Courier"/>
+              </a:rPr>
+              <a:t> </a:t>
+            </a:r>
+            <a:r>
+              <a:rPr b="1">
+                <a:solidFill>
+                  <a:srgbClr val="FF0000"/>
+                </a:solidFill>
+                <a:latin typeface="Courier"/>
+              </a:rPr>
+              <a:t>...</a:t>
+            </a:r>
+            <a:br/>
+            <a:r>
+              <a:rPr>
+                <a:latin typeface="Courier"/>
+              </a:rPr>
+              <a:t>      </a:t>
+            </a:r>
+            <a:r>
+              <a:rPr>
+                <a:solidFill>
+                  <a:srgbClr val="007020"/>
+                </a:solidFill>
+                <a:latin typeface="Courier"/>
+              </a:rPr>
+              <a:t>]</a:t>
+            </a:r>
+            <a:br/>
+            <a:r>
+              <a:rPr>
+                <a:latin typeface="Courier"/>
+              </a:rPr>
+              <a:t>    </a:t>
+            </a:r>
+            <a:r>
+              <a:rPr>
+                <a:solidFill>
+                  <a:srgbClr val="06287E"/>
+                </a:solidFill>
+                <a:latin typeface="Courier"/>
+              </a:rPr>
+              <a:t>}</a:t>
+            </a:r>
+            <a:br/>
+            <a:r>
+              <a:rPr>
+                <a:latin typeface="Courier"/>
+              </a:rPr>
+              <a:t>  </a:t>
+            </a:r>
+            <a:r>
+              <a:rPr>
+                <a:solidFill>
+                  <a:srgbClr val="06287E"/>
+                </a:solidFill>
+                <a:latin typeface="Courier"/>
+              </a:rPr>
+              <a:t>},</a:t>
+            </a:r>
+            <a:br/>
+            <a:r>
+              <a:rPr>
+                <a:latin typeface="Courier"/>
+              </a:rPr>
+              <a:t>  </a:t>
+            </a:r>
+            <a:r>
+              <a:rPr>
+                <a:solidFill>
+                  <a:srgbClr val="902000"/>
+                </a:solidFill>
+                <a:latin typeface="Courier"/>
+              </a:rPr>
+              <a:t>"result"</a:t>
+            </a:r>
+            <a:r>
+              <a:rPr>
+                <a:solidFill>
+                  <a:srgbClr val="06287E"/>
+                </a:solidFill>
+                <a:latin typeface="Courier"/>
+              </a:rPr>
+              <a:t>:</a:t>
+            </a:r>
+            <a:r>
+              <a:rPr>
+                <a:latin typeface="Courier"/>
+              </a:rPr>
+              <a:t> </a:t>
+            </a:r>
+            <a:r>
+              <a:rPr>
+                <a:solidFill>
+                  <a:srgbClr val="4070A0"/>
+                </a:solidFill>
+                <a:latin typeface="Courier"/>
+              </a:rPr>
+              <a:t>"PASS"</a:t>
+            </a:r>
+            <a:br/>
+            <a:r>
+              <a:rPr>
+                <a:solidFill>
+                  <a:srgbClr val="06287E"/>
+                </a:solidFill>
+                <a:latin typeface="Courier"/>
+              </a:rPr>
+              <a:t>}</a:t>
+            </a:r>
+          </a:p>
+        </p:txBody>
+      </p:sp>
+    </p:spTree>
+  </p:cSld>
+</p:sld>
+</file>
+
+<file path=ppt/slides/slide13.xml><?xml version="1.0" encoding="utf-8"?>
+<p:sld xmlns:a="http://schemas.openxmlformats.org/drawingml/2006/main" xmlns:r="http://schemas.openxmlformats.org/officeDocument/2006/relationships" xmlns:p="http://schemas.openxmlformats.org/presentationml/2006/main">
+  <p:cSld>
+    <p:spTree>
+      <p:nvGrpSpPr>
+        <p:cNvPr id="1" name=""/>
+        <p:cNvGrpSpPr/>
+        <p:nvPr/>
+      </p:nvGrpSpPr>
+      <p:grpSpPr>
+        <a:xfrm>
+          <a:off x="0" y="0"/>
+          <a:ext cx="0" cy="0"/>
+          <a:chOff x="0" y="0"/>
+          <a:chExt cx="0" cy="0"/>
+        </a:xfrm>
+      </p:grpSpPr>
+      <p:sp>
+        <p:nvSpPr>
+          <p:cNvPr id="3" name="Content Placeholder 2"/>
+          <p:cNvSpPr>
+            <a:spLocks noGrp="1"/>
+          </p:cNvSpPr>
+          <p:nvPr>
+            <p:ph idx="1"/>
+          </p:nvPr>
+        </p:nvSpPr>
+        <p:spPr/>
+        <p:txBody>
+          <a:bodyPr/>
+          <a:lstStyle/>
+          <a:p>
+            <a:pPr lvl="0" indent="0" marL="0">
+              <a:buNone/>
+            </a:pPr>
+            <a:r>
+              <a:rPr/>
+              <a:t>Raw JSON from the public-eval logs; </a:t>
+            </a:r>
+            <a:r>
+              <a:rPr>
+                <a:latin typeface="Courier"/>
+              </a:rPr>
+              <a:t>"..."</a:t>
+            </a:r>
+            <a:r>
+              <a:rPr/>
+              <a:t> marks elided fields. Judges read </a:t>
+            </a:r>
+            <a:r>
+              <a:rPr i="1"/>
+              <a:t>full reasoning</a:t>
+            </a:r>
+            <a:r>
+              <a:rPr/>
+              <a:t> of all 29 candidates ⇒ minority recovery.</a:t>
+            </a:r>
+          </a:p>
+        </p:txBody>
+      </p:sp>
+    </p:spTree>
+  </p:cSld>
+</p:sld>
+</file>
+
+<file path=ppt/slides/slide14.xml><?xml version="1.0" encoding="utf-8"?>
+<p:sld xmlns:a="http://schemas.openxmlformats.org/drawingml/2006/main" xmlns:r="http://schemas.openxmlformats.org/officeDocument/2006/relationships" xmlns:p="http://schemas.openxmlformats.org/presentationml/2006/main">
+  <p:cSld>
+    <p:spTree>
+      <p:nvGrpSpPr>
+        <p:cNvPr id="1" name=""/>
+        <p:cNvGrpSpPr/>
+        <p:nvPr/>
+      </p:nvGrpSpPr>
+      <p:grpSpPr>
+        <a:xfrm>
+          <a:off x="0" y="0"/>
+          <a:ext cx="0" cy="0"/>
+          <a:chOff x="0" y="0"/>
+          <a:chExt cx="0" cy="0"/>
+        </a:xfrm>
+      </p:grpSpPr>
+      <p:sp>
+        <p:nvSpPr>
+          <p:cNvPr id="2" name="Title 1"/>
+          <p:cNvSpPr>
+            <a:spLocks noGrp="1"/>
+          </p:cNvSpPr>
+          <p:nvPr>
+            <p:ph type="title"/>
+          </p:nvPr>
+        </p:nvSpPr>
+        <p:spPr/>
+        <p:txBody>
+          <a:bodyPr/>
+          <a:lstStyle/>
+          <a:p>
+            <a:pPr lvl="0" indent="0" marL="0">
+              <a:buNone/>
+            </a:pPr>
+            <a:r>
+              <a:rPr/>
+              <a:t>(1) + (2) across 130 tasks — modality contributions and judges’ verdicts</a:t>
+            </a:r>
+          </a:p>
+        </p:txBody>
+      </p:sp>
+      <p:pic>
+        <p:nvPicPr>
+          <p:cNvPr descr="figures/methodology_matrix.png" id="0" name="Picture 1"/>
+          <p:cNvPicPr>
+            <a:picLocks noGrp="1" noChangeAspect="1"/>
+          </p:cNvPicPr>
+          <p:nvPr/>
+        </p:nvPicPr>
+        <p:blipFill>
+          <a:blip r:embed="rId3"/>
+          <a:stretch>
+            <a:fillRect/>
+          </a:stretch>
+        </p:blipFill>
+        <p:spPr bwMode="auto">
+          <a:xfrm>
+            <a:off x="2070100" y="1193800"/>
+            <a:ext cx="825500" cy="3390900"/>
+          </a:xfrm>
+          <a:prstGeom prst="rect">
+            <a:avLst/>
+          </a:prstGeom>
+          <a:noFill/>
+          <a:ln w="9525">
+            <a:noFill/>
+            <a:headEnd/>
+            <a:tailEnd/>
+          </a:ln>
+        </p:spPr>
+      </p:pic>
+      <p:sp>
+        <p:nvSpPr>
+          <p:cNvPr id="4" name="Content Placeholder 3"/>
+          <p:cNvSpPr>
+            <a:spLocks noGrp="1"/>
+          </p:cNvSpPr>
+          <p:nvPr>
+            <p:ph idx="2" sz="half"/>
+          </p:nvPr>
+        </p:nvSpPr>
+        <p:spPr/>
+        <p:txBody>
+          <a:bodyPr/>
+          <a:lstStyle/>
+          <a:p>
+            <a:pPr lvl="0" indent="0" marL="0">
+              <a:buNone/>
+            </a:pPr>
+            <a:r>
+              <a:rPr b="1"/>
+              <a:t>How to read</a:t>
+            </a:r>
+            <a:r>
+              <a:rPr/>
+              <a:t> (one row = one of </a:t>
+            </a:r>
+            <a:r>
+              <a:rPr b="1"/>
+              <a:t>130 instances</a:t>
+            </a:r>
+            <a:r>
+              <a:rPr/>
+              <a:t> with full 29-candidate coverage):</a:t>
+            </a:r>
+          </a:p>
+          <a:p>
+            <a:pPr lvl="0"/>
+            <a:r>
+              <a:rPr b="1"/>
+              <a:t>Judges column</a:t>
+            </a:r>
+            <a:r>
+              <a:rPr/>
+              <a:t> (leftmost): the system’s final pass@2 verdict — did the holistic judges submit a correct answer?</a:t>
+            </a:r>
+          </a:p>
+          <a:p>
+            <a:pPr lvl="0"/>
+            <a:r>
+              <a:rPr/>
+              <a:t>Other columns grouped by modality family — </a:t>
+            </a:r>
+            <a:r>
+              <a:rPr b="1"/>
+              <a:t>Text</a:t>
+            </a:r>
+            <a:r>
+              <a:rPr/>
+              <a:t> · </a:t>
+            </a:r>
+            <a:r>
+              <a:rPr b="1"/>
+              <a:t>Image</a:t>
+            </a:r>
+            <a:r>
+              <a:rPr/>
+              <a:t> · </a:t>
+            </a:r>
+            <a:r>
+              <a:rPr b="1"/>
+              <a:t>Code</a:t>
+            </a:r>
+            <a:r>
+              <a:rPr/>
+              <a:t> — each sub-column = one model/config candidate</a:t>
+            </a:r>
+          </a:p>
+          <a:p>
+            <a:pPr lvl="0"/>
+            <a:r>
+              <a:rPr b="1"/>
+              <a:t>Green</a:t>
+            </a:r>
+            <a:r>
+              <a:rPr/>
+              <a:t> = correct · </a:t>
+            </a:r>
+            <a:r>
+              <a:rPr b="1"/>
+              <a:t>Red</a:t>
+            </a:r>
+            <a:r>
+              <a:rPr/>
+              <a:t> = wrong</a:t>
+            </a:r>
+          </a:p>
+          <a:p>
+            <a:pPr lvl="0"/>
+            <a:r>
+              <a:rPr/>
+              <a:t>Rows sorted by difficulty: hardest tasks top, easiest bottom</a:t>
+            </a:r>
+          </a:p>
+          <a:p>
+            <a:pPr lvl="0" indent="0" marL="0">
+              <a:buNone/>
+            </a:pPr>
+            <a:r>
+              <a:rPr b="1"/>
+              <a:t>Three bands tell the story</a:t>
+            </a:r>
+            <a:r>
+              <a:rPr/>
+              <a:t>:</a:t>
+            </a:r>
+          </a:p>
+          <a:p>
+            <a:pPr lvl="0"/>
+            <a:r>
+              <a:rPr b="1"/>
+              <a:t>Top:</a:t>
+            </a:r>
+            <a:r>
+              <a:rPr/>
+              <a:t> all-red rows — generation failures (no modality solved them)</a:t>
+            </a:r>
+          </a:p>
+          <a:p>
+            <a:pPr lvl="0"/>
+            <a:r>
+              <a:rPr b="1"/>
+              <a:t>Middle:</a:t>
+            </a:r>
+            <a:r>
+              <a:rPr/>
+              <a:t> </a:t>
+            </a:r>
+            <a:r>
+              <a:rPr i="1"/>
+              <a:t>scattered green cells in mostly-red rows</a:t>
+            </a:r>
+            <a:r>
+              <a:rPr/>
+              <a:t> ⇒ different modalities catch different problems</a:t>
+            </a:r>
+          </a:p>
+          <a:p>
+            <a:pPr lvl="0"/>
+            <a:r>
+              <a:rPr b="1"/>
+              <a:t>Bottom:</a:t>
+            </a:r>
+            <a:r>
+              <a:rPr/>
+              <a:t> mostly green — the easy tasks (many modalities solve)</a:t>
+            </a:r>
+          </a:p>
+          <a:p>
+            <a:pPr lvl="0" indent="0" marL="0">
+              <a:buNone/>
+            </a:pPr>
+            <a:r>
+              <a:rPr b="1"/>
+              <a:t>Edge case — Judges green, all candidates red</a:t>
+            </a:r>
+            <a:r>
+              <a:rPr/>
+              <a:t>: a </a:t>
+            </a:r>
+            <a:r>
+              <a:rPr i="1"/>
+              <a:t>judge-synthesis</a:t>
+            </a:r>
+            <a:r>
+              <a:rPr/>
+              <a:t> solve. Happens on </a:t>
+            </a:r>
+            <a:r>
+              <a:rPr>
+                <a:latin typeface="Courier"/>
+              </a:rPr>
+              <a:t>21897d95:2</a:t>
+            </a:r>
+            <a:r>
+              <a:rPr/>
+              <a:t>: zero candidates correct, but a judge </a:t>
+            </a:r>
+            <a:r>
+              <a:rPr b="1"/>
+              <a:t>recombined partial insights</a:t>
+            </a:r>
+            <a:r>
+              <a:rPr/>
+              <a:t> across failed candidates into a novel correct output.</a:t>
+            </a:r>
+          </a:p>
+          <a:p>
+            <a:pPr lvl="0" indent="0" marL="0">
+              <a:buNone/>
+            </a:pPr>
+            <a:r>
+              <a:rPr b="1"/>
+              <a:t>What the numbers say</a:t>
+            </a:r>
+            <a:r>
+              <a:rPr/>
+              <a:t> (n=130):</a:t>
+            </a:r>
+          </a:p>
+          <a:p>
+            <a:pPr lvl="0"/>
+            <a:r>
+              <a:rPr/>
+              <a:t>Exclusive solves: </a:t>
+            </a:r>
+            <a:r>
+              <a:rPr b="1"/>
+              <a:t>2 Text-only</a:t>
+            </a:r>
+            <a:r>
+              <a:rPr/>
+              <a:t> · </a:t>
+            </a:r>
+            <a:r>
+              <a:rPr b="1"/>
+              <a:t>6 Image-only</a:t>
+            </a:r>
+            <a:r>
+              <a:rPr/>
+              <a:t> · </a:t>
+            </a:r>
+            <a:r>
+              <a:rPr b="1"/>
+              <a:t>7 Code-only</a:t>
+            </a:r>
+          </a:p>
+          <a:p>
+            <a:pPr lvl="0"/>
+            <a:r>
+              <a:rPr/>
+              <a:t>Pairwise non-overlap: Code solves </a:t>
+            </a:r>
+            <a:r>
+              <a:rPr b="1"/>
+              <a:t>+18</a:t>
+            </a:r>
+            <a:r>
+              <a:rPr/>
+              <a:t> over Text · Image solves </a:t>
+            </a:r>
+            <a:r>
+              <a:rPr b="1"/>
+              <a:t>+13</a:t>
+            </a:r>
+            <a:r>
+              <a:rPr/>
+              <a:t> over Text</a:t>
+            </a:r>
+          </a:p>
+          <a:p>
+            <a:pPr lvl="0"/>
+            <a:r>
+              <a:rPr b="1"/>
+              <a:t>Candidate-oracle: 86.2%</a:t>
+            </a:r>
+            <a:r>
+              <a:rPr/>
+              <a:t> — a correct candidate exists for 144/167 instances overall</a:t>
+            </a:r>
+          </a:p>
+          <a:p>
+            <a:pPr lvl="0"/>
+            <a:r>
+              <a:rPr/>
+              <a:t>Modalities are </a:t>
+            </a:r>
+            <a:r>
+              <a:rPr b="1"/>
+              <a:t>not redundant copies</a:t>
+            </a:r>
+            <a:r>
+              <a:rPr/>
+              <a:t> of each other</a:t>
+            </a:r>
+          </a:p>
+        </p:txBody>
+      </p:sp>
+    </p:spTree>
+  </p:cSld>
+</p:sld>
+</file>
+
+<file path=ppt/slides/slide15.xml><?xml version="1.0" encoding="utf-8"?>
+<p:sld xmlns:a="http://schemas.openxmlformats.org/drawingml/2006/main" xmlns:r="http://schemas.openxmlformats.org/officeDocument/2006/relationships" xmlns:p="http://schemas.openxmlformats.org/presentationml/2006/main">
+  <p:cSld>
+    <p:spTree>
+      <p:nvGrpSpPr>
+        <p:cNvPr id="1" name=""/>
+        <p:cNvGrpSpPr/>
+        <p:nvPr/>
+      </p:nvGrpSpPr>
+      <p:grpSpPr>
+        <a:xfrm>
+          <a:off x="0" y="0"/>
+          <a:ext cx="0" cy="0"/>
+          <a:chOff x="0" y="0"/>
+          <a:chExt cx="0" cy="0"/>
+        </a:xfrm>
+      </p:grpSpPr>
+      <p:sp>
+        <p:nvSpPr>
+          <p:cNvPr id="2" name="Title 1"/>
+          <p:cNvSpPr>
+            <a:spLocks noGrp="1"/>
+          </p:cNvSpPr>
+          <p:nvPr>
+            <p:ph type="title"/>
+          </p:nvPr>
+        </p:nvSpPr>
+        <p:spPr/>
+        <p:txBody>
+          <a:bodyPr/>
+          <a:lstStyle/>
+          <a:p>
+            <a:pPr lvl="0" indent="0" marL="0">
+              <a:buNone/>
+            </a:pPr>
+            <a:r>
+              <a:rPr/>
+              <a:t>Negative results worth knowing</a:t>
+            </a:r>
+          </a:p>
+        </p:txBody>
+      </p:sp>
+      <p:sp>
+        <p:nvSpPr>
+          <p:cNvPr id="3" name="Content Placeholder 2"/>
+          <p:cNvSpPr>
+            <a:spLocks noGrp="1"/>
+          </p:cNvSpPr>
+          <p:nvPr>
+            <p:ph idx="1"/>
+          </p:nvPr>
+        </p:nvSpPr>
+        <p:spPr/>
+        <p:txBody>
+          <a:bodyPr/>
+          <a:lstStyle/>
+          <a:p>
+            <a:pPr lvl="0" indent="0" marL="0">
+              <a:buNone/>
+            </a:pPr>
+            <a:r>
+              <a:rPr b="1"/>
+              <a:t>1. Prescriptive prompting degrades performance.</a:t>
+            </a:r>
+            <a:r>
+              <a:rPr/>
+              <a:t> Templates, CoT scaffolding, domain heuristics — all hurt on the hardest tasks. Mechanism: a </a:t>
+            </a:r>
+            <a:r>
+              <a:rPr i="1"/>
+              <a:t>compliance tax on reasoning</a:t>
+            </a:r>
+            <a:r>
+              <a:rPr/>
+              <a:t> (budget spent following the template instead of solving the problem).</a:t>
+            </a:r>
+          </a:p>
+          <a:p>
+            <a:pPr lvl="0" indent="0" marL="0">
+              <a:buNone/>
+            </a:pPr>
+            <a:r>
+              <a:rPr b="1"/>
+              <a:t>2. Iterative refinement reduces diversity.</a:t>
+            </a:r>
+            <a:r>
+              <a:rPr/>
+              <a:t> Refining candidates against each other collapses them onto the same wrong cluster — the exact failure mode we’re trying to escape. Same effect from hint-then-solve pipelines.</a:t>
+            </a:r>
+          </a:p>
+          <a:p>
+            <a:pPr lvl="0" indent="0" marL="0">
+              <a:buNone/>
+            </a:pPr>
+            <a:r>
+              <a:rPr b="1"/>
+              <a:t>3. Pipeline decomposition (objects → transformations → solver) hurts.</a:t>
+            </a:r>
+            <a:r>
+              <a:rPr/>
+              <a:t> Brittle handoffs between stages. Both verbose and terse handovers regress toward the mean rather than expand the hypothesis space.</a:t>
+            </a:r>
+          </a:p>
+          <a:p>
+            <a:pPr lvl="0" indent="0" marL="0">
+              <a:buNone/>
+            </a:pPr>
+            <a:r>
+              <a:rPr b="1"/>
+              <a:t>4. Strict JSON outputs underperform CSV.</a:t>
+            </a:r>
+            <a:r>
+              <a:rPr/>
+              <a:t> Forcing API-level response-format schemas consistently lost to CSV + robust regex parsing. Strict schemas appear to constrain reasoning quality, not just output shape.</a:t>
+            </a:r>
+          </a:p>
+          <a:p>
+            <a:pPr lvl="0" indent="0" marL="0">
+              <a:buNone/>
+            </a:pPr>
+            <a:r>
+              <a:rPr b="1"/>
+              <a:t>5. Pixel-perfect image renderings hurt.</a:t>
+            </a:r>
+            <a:r>
+              <a:rPr/>
+              <a:t> </a:t>
+            </a:r>
+            <a:r>
+              <a:rPr i="1"/>
+              <a:t>Slightly distorted</a:t>
+            </a:r>
+            <a:r>
+              <a:rPr/>
+              <a:t> renders beat pixel-perfect ones for image-modality candidates. Clean renders push the model into cell-by-cell numerical reasoning; intentional imprecision forces engagement with shapes, symmetries, and spatial relationships — which is the point of image prompting.</a:t>
+            </a:r>
+          </a:p>
+          <a:p>
+            <a:pPr lvl="0" indent="0" marL="0">
+              <a:buNone/>
+            </a:pPr>
+            <a:r>
+              <a:rPr/>
+              <a:t>⇒ </a:t>
+            </a:r>
+            <a:r>
+              <a:rPr b="1"/>
+              <a:t>Final system: deliberately minimal prompts, independent generation, no decomposition, CSV I/O, deliberately fuzzy image renders.</a:t>
+            </a:r>
+          </a:p>
+        </p:txBody>
+      </p:sp>
+    </p:spTree>
+  </p:cSld>
+</p:sld>
+</file>
+
+<file path=ppt/slides/slide16.xml><?xml version="1.0" encoding="utf-8"?>
+<p:sld xmlns:a="http://schemas.openxmlformats.org/drawingml/2006/main" xmlns:r="http://schemas.openxmlformats.org/officeDocument/2006/relationships" xmlns:p="http://schemas.openxmlformats.org/presentationml/2006/main">
+  <p:cSld>
+    <p:spTree>
+      <p:nvGrpSpPr>
+        <p:cNvPr id="1" name=""/>
+        <p:cNvGrpSpPr/>
+        <p:nvPr/>
+      </p:nvGrpSpPr>
+      <p:grpSpPr>
+        <a:xfrm>
+          <a:off x="0" y="0"/>
+          <a:ext cx="0" cy="0"/>
+          <a:chOff x="0" y="0"/>
+          <a:chExt cx="0" cy="0"/>
+        </a:xfrm>
+      </p:grpSpPr>
+      <p:sp>
+        <p:nvSpPr>
+          <p:cNvPr id="2" name="Title 1"/>
+          <p:cNvSpPr>
+            <a:spLocks noGrp="1"/>
+          </p:cNvSpPr>
+          <p:nvPr>
+            <p:ph type="title"/>
+          </p:nvPr>
+        </p:nvSpPr>
+        <p:spPr/>
+        <p:txBody>
+          <a:bodyPr/>
+          <a:lstStyle/>
+          <a:p>
+            <a:pPr lvl="0" indent="0" marL="0">
+              <a:buNone/>
+            </a:pPr>
+            <a:r>
+              <a:rPr/>
+              <a:t>Takeaways</a:t>
+            </a:r>
+          </a:p>
+        </p:txBody>
+      </p:sp>
+      <p:sp>
+        <p:nvSpPr>
+          <p:cNvPr id="3" name="Content Placeholder 2"/>
+          <p:cNvSpPr>
+            <a:spLocks noGrp="1"/>
+          </p:cNvSpPr>
+          <p:nvPr>
+            <p:ph idx="1"/>
+          </p:nvPr>
+        </p:nvSpPr>
+        <p:spPr/>
+        <p:txBody>
+          <a:bodyPr/>
+          <a:lstStyle/>
+          <a:p>
+            <a:pPr lvl="0" indent="0" marL="0">
+              <a:buNone/>
+            </a:pPr>
+            <a:r>
+              <a:rPr b="1"/>
+              <a:t>(1) Generate broadly</a:t>
+            </a:r>
+            <a:r>
+              <a:rPr/>
+              <a:t> — different modalities (text, image, code) and different frontier models, generated </a:t>
+            </a:r>
+            <a:r>
+              <a:rPr i="1"/>
+              <a:t>independently</a:t>
+            </a:r>
+            <a:r>
+              <a:rPr/>
+              <a:t>. The hypothesis space matters more than the model.</a:t>
+            </a:r>
+          </a:p>
+          <a:p>
+            <a:pPr lvl="0" indent="0" marL="0">
+              <a:buNone/>
+            </a:pPr>
+            <a:r>
+              <a:rPr b="1"/>
+              <a:t>(2) Judge holistically</a:t>
+            </a:r>
+            <a:r>
+              <a:rPr/>
+              <a:t> — a long-context judge reads the </a:t>
+            </a:r>
+            <a:r>
+              <a:rPr i="1"/>
+              <a:t>full reasoning</a:t>
+            </a:r>
+            <a:r>
+              <a:rPr/>
+              <a:t>, not just final answers. Majority voting discards the rare-correct; trace-aware judging recovers it (and occasionally synthesizes a new one).</a:t>
+            </a:r>
+          </a:p>
+          <a:p>
+            <a:pPr lvl="0" indent="0" marL="0">
+              <a:buNone/>
+            </a:pPr>
+            <a:r>
+              <a:rPr b="1"/>
+              <a:t>Where this generalizes:</a:t>
+            </a:r>
+            <a:r>
+              <a:rPr/>
+              <a:t> any hard problem where the </a:t>
+            </a:r>
+            <a:r>
+              <a:rPr i="1"/>
+              <a:t>reasoning</a:t>
+            </a:r>
+            <a:r>
+              <a:rPr/>
+              <a:t> signals correctness — even when the answer itself can’t be verified directly. As in ARC: the judges never see the test output; they assess the </a:t>
+            </a:r>
+            <a:r>
+              <a:rPr b="1"/>
+              <a:t>credibility of each trace</a:t>
+            </a:r>
+            <a:r>
+              <a:rPr/>
+              <a:t> against the training pairs. Math contests, code review, legal arguments, scientific hypotheses — wherever a careful reader can tell sound reasoning from rationalization.</a:t>
+            </a:r>
+          </a:p>
+          <a:p>
+            <a:pPr lvl="0" indent="0" marL="0">
+              <a:buNone/>
+            </a:pPr>
+            <a:r>
+              <a:rPr/>
+              <a:t>Code: </a:t>
+            </a:r>
+            <a:r>
+              <a:rPr>
+                <a:latin typeface="Courier"/>
+              </a:rPr>
+              <a:t>github.com/beetree/ARC-AGI</a:t>
+            </a:r>
+            <a:r>
+              <a:rPr/>
+              <a:t> · Paper QR on title slide</a:t>
+            </a:r>
+          </a:p>
+        </p:txBody>
+      </p:sp>
+    </p:spTree>
+  </p:cSld>
+</p:sld>
+</file>
+
+<file path=ppt/slides/slide17.xml><?xml version="1.0" encoding="utf-8"?>
 <p:sld xmlns:a="http://schemas.openxmlformats.org/drawingml/2006/main" xmlns:r="http://schemas.openxmlformats.org/officeDocument/2006/relationships" xmlns:p="http://schemas.openxmlformats.org/presentationml/2006/main">
   <p:cSld>
     <p:spTree>
@@ -4964,7 +7986,7 @@
 </p:sld>
 </file>
 
-<file path=ppt/slides/slide11.xml><?xml version="1.0" encoding="utf-8"?>
+<file path=ppt/slides/slide18.xml><?xml version="1.0" encoding="utf-8"?>
 <p:sld xmlns:a="http://schemas.openxmlformats.org/drawingml/2006/main" xmlns:r="http://schemas.openxmlformats.org/officeDocument/2006/relationships" xmlns:p="http://schemas.openxmlformats.org/presentationml/2006/main">
   <p:cSld>
     <p:spTree>
@@ -5001,49 +8023,19 @@
             </a:pPr>
             <a:r>
               <a:rPr/>
-              <a:t>Modality complementarity</a:t>
-            </a:r>
-          </a:p>
-        </p:txBody>
-      </p:sp>
-      <p:pic>
-        <p:nvPicPr>
-          <p:cNvPr descr="figures/methodology_matrix.png" id="0" name="Picture 1"/>
-          <p:cNvPicPr>
-            <a:picLocks noGrp="1" noChangeAspect="1"/>
-          </p:cNvPicPr>
-          <p:nvPr/>
-        </p:nvPicPr>
-        <p:blipFill>
-          <a:blip r:embed="rId3"/>
-          <a:stretch>
-            <a:fillRect/>
-          </a:stretch>
-        </p:blipFill>
-        <p:spPr bwMode="auto">
-          <a:xfrm>
-            <a:off x="2082800" y="1193800"/>
-            <a:ext cx="787400" cy="3390900"/>
-          </a:xfrm>
-          <a:prstGeom prst="rect">
-            <a:avLst/>
-          </a:prstGeom>
-          <a:noFill/>
-          <a:ln w="9525">
-            <a:noFill/>
-            <a:headEnd/>
-            <a:tailEnd/>
-          </a:ln>
-        </p:spPr>
-      </p:pic>
-      <p:sp>
-        <p:nvSpPr>
-          <p:cNvPr id="4" name="Content Placeholder 3"/>
-          <p:cNvSpPr>
-            <a:spLocks noGrp="1"/>
-          </p:cNvSpPr>
-          <p:nvPr>
-            <p:ph idx="2" sz="half"/>
+              <a:t>Backup: cost breakdown</a:t>
+            </a:r>
+          </a:p>
+        </p:txBody>
+      </p:sp>
+      <p:sp>
+        <p:nvSpPr>
+          <p:cNvPr id="3" name="Content Placeholder 2"/>
+          <p:cNvSpPr>
+            <a:spLocks noGrp="1"/>
+          </p:cNvSpPr>
+          <p:nvPr>
+            <p:ph idx="1"/>
           </p:nvPr>
         </p:nvSpPr>
         <p:spPr/>
@@ -5053,65 +8045,36 @@
           <a:p>
             <a:pPr lvl="0"/>
             <a:r>
-              <a:rPr/>
-              <a:t>Pairwise non-overlap (n=130): Code solves 18 that Text misses; Image solves 13 that Text misses</a:t>
+              <a:rPr b="1"/>
+              <a:t>Public-eval cost is the representative number: $19.69/task</a:t>
             </a:r>
           </a:p>
           <a:p>
             <a:pPr lvl="0"/>
             <a:r>
               <a:rPr/>
-              <a:t>Exclusive: </a:t>
-            </a:r>
-            <a:r>
-              <a:rPr b="1"/>
-              <a:t>2 Text-only</a:t>
-            </a:r>
-            <a:r>
-              <a:rPr/>
-              <a:t>, </a:t>
-            </a:r>
-            <a:r>
-              <a:rPr b="1"/>
-              <a:t>6 Image-only</a:t>
-            </a:r>
-            <a:r>
-              <a:rPr/>
-              <a:t>, </a:t>
-            </a:r>
-            <a:r>
-              <a:rPr b="1"/>
-              <a:t>7 Code-only</a:t>
+              <a:t>Private $38.99/task inflated by GPT-5.2 API instability (84% failure rate, 2,216/14,106 attempts succeeded)</a:t>
             </a:r>
           </a:p>
           <a:p>
             <a:pPr lvl="0"/>
             <a:r>
               <a:rPr/>
-              <a:t>Modalities are </a:t>
-            </a:r>
-            <a:r>
-              <a:rPr b="1"/>
-              <a:t>not redundant copies</a:t>
-            </a:r>
-            <a:r>
-              <a:rPr/>
-              <a:t> of the same reasoning process</a:t>
+              <a:t>Tool-integrated code generation is the largest line item</a:t>
             </a:r>
           </a:p>
           <a:p>
             <a:pPr lvl="0"/>
             <a:r>
               <a:rPr/>
-              <a:t>Candidate-oracle accuracy: </a:t>
-            </a:r>
-            <a:r>
-              <a:rPr b="1"/>
-              <a:t>86.2%</a:t>
-            </a:r>
-            <a:r>
-              <a:rPr/>
-              <a:t> (correct candidate exists for 144/167)</a:t>
+              <a:t>ZDR mode used in private verification disables tool calls → both lower accuracy and altered cost profile</a:t>
+            </a:r>
+          </a:p>
+          <a:p>
+            <a:pPr lvl="0"/>
+            <a:r>
+              <a:rPr/>
+              <a:t>ARC-AGI-1 on the same system: 94.5% at $11.40/task — easier tasks early-exit cheaply</a:t>
             </a:r>
           </a:p>
         </p:txBody>
@@ -5121,7 +8084,7 @@
 </p:sld>
 </file>
 
-<file path=ppt/slides/slide12.xml><?xml version="1.0" encoding="utf-8"?>
+<file path=ppt/slides/slide19.xml><?xml version="1.0" encoding="utf-8"?>
 <p:sld xmlns:a="http://schemas.openxmlformats.org/drawingml/2006/main" xmlns:r="http://schemas.openxmlformats.org/officeDocument/2006/relationships" xmlns:p="http://schemas.openxmlformats.org/presentationml/2006/main">
   <p:cSld>
     <p:spTree>
@@ -5158,345 +8121,6 @@
             </a:pPr>
             <a:r>
               <a:rPr/>
-              <a:t>Negative results worth knowing</a:t>
-            </a:r>
-          </a:p>
-        </p:txBody>
-      </p:sp>
-      <p:sp>
-        <p:nvSpPr>
-          <p:cNvPr id="3" name="Content Placeholder 2"/>
-          <p:cNvSpPr>
-            <a:spLocks noGrp="1"/>
-          </p:cNvSpPr>
-          <p:nvPr>
-            <p:ph idx="1"/>
-          </p:nvPr>
-        </p:nvSpPr>
-        <p:spPr/>
-        <p:txBody>
-          <a:bodyPr/>
-          <a:lstStyle/>
-          <a:p>
-            <a:pPr lvl="0" indent="0" marL="0">
-              <a:buNone/>
-            </a:pPr>
-            <a:r>
-              <a:rPr b="1"/>
-              <a:t>Prescriptive prompting degrades performance</a:t>
-            </a:r>
-          </a:p>
-          <a:p>
-            <a:pPr lvl="0" indent="0" marL="0">
-              <a:buNone/>
-            </a:pPr>
-            <a:r>
-              <a:rPr/>
-              <a:t>Structured templates, CoT scaffolding, domain heuristics — all hurt on the hardest tasks. Mechanism: a </a:t>
-            </a:r>
-            <a:r>
-              <a:rPr i="1"/>
-              <a:t>compliance tax on reasoning</a:t>
-            </a:r>
-            <a:r>
-              <a:rPr/>
-              <a:t>.</a:t>
-            </a:r>
-          </a:p>
-          <a:p>
-            <a:pPr lvl="0" indent="0" marL="0">
-              <a:buNone/>
-            </a:pPr>
-            <a:r>
-              <a:rPr b="1"/>
-              <a:t>Iterative refinement reduces diversity</a:t>
-            </a:r>
-          </a:p>
-          <a:p>
-            <a:pPr lvl="0" indent="0" marL="0">
-              <a:buNone/>
-            </a:pPr>
-            <a:r>
-              <a:rPr/>
-              <a:t>Refining candidates against each other collapses them onto the same wrong cluster — the exact failure mode we’re trying to escape.</a:t>
-            </a:r>
-          </a:p>
-          <a:p>
-            <a:pPr lvl="0" indent="0" marL="0">
-              <a:buNone/>
-            </a:pPr>
-            <a:r>
-              <a:rPr/>
-              <a:t>⇒ </a:t>
-            </a:r>
-            <a:r>
-              <a:rPr b="1"/>
-              <a:t>Final system: deliberately minimal prompts + independent generation</a:t>
-            </a:r>
-          </a:p>
-        </p:txBody>
-      </p:sp>
-    </p:spTree>
-  </p:cSld>
-</p:sld>
-</file>
-
-<file path=ppt/slides/slide13.xml><?xml version="1.0" encoding="utf-8"?>
-<p:sld xmlns:a="http://schemas.openxmlformats.org/drawingml/2006/main" xmlns:r="http://schemas.openxmlformats.org/officeDocument/2006/relationships" xmlns:p="http://schemas.openxmlformats.org/presentationml/2006/main">
-  <p:cSld>
-    <p:spTree>
-      <p:nvGrpSpPr>
-        <p:cNvPr id="1" name=""/>
-        <p:cNvGrpSpPr/>
-        <p:nvPr/>
-      </p:nvGrpSpPr>
-      <p:grpSpPr>
-        <a:xfrm>
-          <a:off x="0" y="0"/>
-          <a:ext cx="0" cy="0"/>
-          <a:chOff x="0" y="0"/>
-          <a:chExt cx="0" cy="0"/>
-        </a:xfrm>
-      </p:grpSpPr>
-      <p:sp>
-        <p:nvSpPr>
-          <p:cNvPr id="2" name="Title 1"/>
-          <p:cNvSpPr>
-            <a:spLocks noGrp="1"/>
-          </p:cNvSpPr>
-          <p:nvPr>
-            <p:ph type="title"/>
-          </p:nvPr>
-        </p:nvSpPr>
-        <p:spPr/>
-        <p:txBody>
-          <a:bodyPr/>
-          <a:lstStyle/>
-          <a:p>
-            <a:pPr lvl="0" indent="0" marL="0">
-              <a:buNone/>
-            </a:pPr>
-            <a:r>
-              <a:rPr/>
-              <a:t>Takeaways</a:t>
-            </a:r>
-          </a:p>
-        </p:txBody>
-      </p:sp>
-      <p:sp>
-        <p:nvSpPr>
-          <p:cNvPr id="3" name="Content Placeholder 2"/>
-          <p:cNvSpPr>
-            <a:spLocks noGrp="1"/>
-          </p:cNvSpPr>
-          <p:nvPr>
-            <p:ph idx="1"/>
-          </p:nvPr>
-        </p:nvSpPr>
-        <p:spPr/>
-        <p:txBody>
-          <a:bodyPr/>
-          <a:lstStyle/>
-          <a:p>
-            <a:pPr lvl="0" indent="-342900" marL="342900">
-              <a:buAutoNum type="arabicPeriod"/>
-            </a:pPr>
-            <a:r>
-              <a:rPr b="1"/>
-              <a:t>Modalities are search operators.</a:t>
-            </a:r>
-            <a:r>
-              <a:rPr/>
-              <a:t> Text, image, code activate different hypothesis distributions — exploit that.</a:t>
-            </a:r>
-          </a:p>
-          <a:p>
-            <a:pPr lvl="0" indent="-342900" marL="342900">
-              <a:buAutoNum type="arabicPeriod"/>
-            </a:pPr>
-            <a:r>
-              <a:rPr b="1"/>
-              <a:t>Holistic judging &gt; majority voting.</a:t>
-            </a:r>
-            <a:r>
-              <a:rPr/>
-              <a:t> On hard tasks the truth is a minority hypothesis; let a long-context judge read full traces.</a:t>
-            </a:r>
-          </a:p>
-          <a:p>
-            <a:pPr lvl="0" indent="-342900" marL="342900">
-              <a:buAutoNum type="arabicPeriod"/>
-            </a:pPr>
-            <a:r>
-              <a:rPr b="1"/>
-              <a:t>Less prompt structure, more representational diversity.</a:t>
-            </a:r>
-            <a:r>
-              <a:rPr/>
-              <a:t> Prescriptive scaffolding suppresses the creative leaps these tasks reward.</a:t>
-            </a:r>
-          </a:p>
-          <a:p>
-            <a:pPr lvl="0" indent="0" marL="0">
-              <a:buNone/>
-            </a:pPr>
-            <a:r>
-              <a:rPr/>
-              <a:t>Code: </a:t>
-            </a:r>
-            <a:r>
-              <a:rPr>
-                <a:latin typeface="Courier"/>
-              </a:rPr>
-              <a:t>github.com/beetree/ARC-AGI</a:t>
-            </a:r>
-            <a:r>
-              <a:rPr/>
-              <a:t> • Paper QR on title slide</a:t>
-            </a:r>
-          </a:p>
-        </p:txBody>
-      </p:sp>
-    </p:spTree>
-  </p:cSld>
-</p:sld>
-</file>
-
-<file path=ppt/slides/slide14.xml><?xml version="1.0" encoding="utf-8"?>
-<p:sld xmlns:a="http://schemas.openxmlformats.org/drawingml/2006/main" xmlns:r="http://schemas.openxmlformats.org/officeDocument/2006/relationships" xmlns:p="http://schemas.openxmlformats.org/presentationml/2006/main">
-  <p:cSld>
-    <p:spTree>
-      <p:nvGrpSpPr>
-        <p:cNvPr id="1" name=""/>
-        <p:cNvGrpSpPr/>
-        <p:nvPr/>
-      </p:nvGrpSpPr>
-      <p:grpSpPr>
-        <a:xfrm>
-          <a:off x="0" y="0"/>
-          <a:ext cx="0" cy="0"/>
-          <a:chOff x="0" y="0"/>
-          <a:chExt cx="0" cy="0"/>
-        </a:xfrm>
-      </p:grpSpPr>
-      <p:sp>
-        <p:nvSpPr>
-          <p:cNvPr id="2" name="Title 1"/>
-          <p:cNvSpPr>
-            <a:spLocks noGrp="1"/>
-          </p:cNvSpPr>
-          <p:nvPr>
-            <p:ph type="title"/>
-          </p:nvPr>
-        </p:nvSpPr>
-        <p:spPr/>
-        <p:txBody>
-          <a:bodyPr/>
-          <a:lstStyle/>
-          <a:p>
-            <a:pPr lvl="0" indent="0" marL="0">
-              <a:buNone/>
-            </a:pPr>
-            <a:r>
-              <a:rPr/>
-              <a:t>Backup: cost breakdown</a:t>
-            </a:r>
-          </a:p>
-        </p:txBody>
-      </p:sp>
-      <p:sp>
-        <p:nvSpPr>
-          <p:cNvPr id="3" name="Content Placeholder 2"/>
-          <p:cNvSpPr>
-            <a:spLocks noGrp="1"/>
-          </p:cNvSpPr>
-          <p:nvPr>
-            <p:ph idx="1"/>
-          </p:nvPr>
-        </p:nvSpPr>
-        <p:spPr/>
-        <p:txBody>
-          <a:bodyPr/>
-          <a:lstStyle/>
-          <a:p>
-            <a:pPr lvl="0"/>
-            <a:r>
-              <a:rPr b="1"/>
-              <a:t>Public-eval cost is the representative number: $19.69/task</a:t>
-            </a:r>
-          </a:p>
-          <a:p>
-            <a:pPr lvl="0"/>
-            <a:r>
-              <a:rPr/>
-              <a:t>Semi-private $38.99/task inflated by GPT-5.2 API instability (84% failure rate, 2,216/14,106 attempts succeeded)</a:t>
-            </a:r>
-          </a:p>
-          <a:p>
-            <a:pPr lvl="0"/>
-            <a:r>
-              <a:rPr/>
-              <a:t>Tool-integrated code generation is the largest line item</a:t>
-            </a:r>
-          </a:p>
-          <a:p>
-            <a:pPr lvl="0"/>
-            <a:r>
-              <a:rPr/>
-              <a:t>ZDR mode used in semi-private verification disables tool calls → both lower accuracy and altered cost profile</a:t>
-            </a:r>
-          </a:p>
-          <a:p>
-            <a:pPr lvl="0"/>
-            <a:r>
-              <a:rPr/>
-              <a:t>ARC-AGI-1 on the same system: 94.5% at $11.40/task — easier tasks early-exit cheaply</a:t>
-            </a:r>
-          </a:p>
-        </p:txBody>
-      </p:sp>
-    </p:spTree>
-  </p:cSld>
-</p:sld>
-</file>
-
-<file path=ppt/slides/slide15.xml><?xml version="1.0" encoding="utf-8"?>
-<p:sld xmlns:a="http://schemas.openxmlformats.org/drawingml/2006/main" xmlns:r="http://schemas.openxmlformats.org/officeDocument/2006/relationships" xmlns:p="http://schemas.openxmlformats.org/presentationml/2006/main">
-  <p:cSld>
-    <p:spTree>
-      <p:nvGrpSpPr>
-        <p:cNvPr id="1" name=""/>
-        <p:cNvGrpSpPr/>
-        <p:nvPr/>
-      </p:nvGrpSpPr>
-      <p:grpSpPr>
-        <a:xfrm>
-          <a:off x="0" y="0"/>
-          <a:ext cx="0" cy="0"/>
-          <a:chOff x="0" y="0"/>
-          <a:chExt cx="0" cy="0"/>
-        </a:xfrm>
-      </p:grpSpPr>
-      <p:sp>
-        <p:nvSpPr>
-          <p:cNvPr id="2" name="Title 1"/>
-          <p:cNvSpPr>
-            <a:spLocks noGrp="1"/>
-          </p:cNvSpPr>
-          <p:nvPr>
-            <p:ph type="title"/>
-          </p:nvPr>
-        </p:nvSpPr>
-        <p:spPr/>
-        <p:txBody>
-          <a:bodyPr/>
-          <a:lstStyle/>
-          <a:p>
-            <a:pPr lvl="0" indent="0" marL="0">
-              <a:buNone/>
-            </a:pPr>
-            <a:r>
-              <a:rPr/>
               <a:t>Backup: failure decomposition (167 instances)</a:t>
             </a:r>
           </a:p>
@@ -5586,98 +8210,6 @@
             <a:r>
               <a:rPr i="1"/>
               <a:t>Most future headroom is in selection, not generation.</a:t>
-            </a:r>
-          </a:p>
-        </p:txBody>
-      </p:sp>
-    </p:spTree>
-  </p:cSld>
-</p:sld>
-</file>
-
-<file path=ppt/slides/slide16.xml><?xml version="1.0" encoding="utf-8"?>
-<p:sld xmlns:a="http://schemas.openxmlformats.org/drawingml/2006/main" xmlns:r="http://schemas.openxmlformats.org/officeDocument/2006/relationships" xmlns:p="http://schemas.openxmlformats.org/presentationml/2006/main">
-  <p:cSld>
-    <p:spTree>
-      <p:nvGrpSpPr>
-        <p:cNvPr id="1" name=""/>
-        <p:cNvGrpSpPr/>
-        <p:nvPr/>
-      </p:nvGrpSpPr>
-      <p:grpSpPr>
-        <a:xfrm>
-          <a:off x="0" y="0"/>
-          <a:ext cx="0" cy="0"/>
-          <a:chOff x="0" y="0"/>
-          <a:chExt cx="0" cy="0"/>
-        </a:xfrm>
-      </p:grpSpPr>
-      <p:sp>
-        <p:nvSpPr>
-          <p:cNvPr id="2" name="Title 1"/>
-          <p:cNvSpPr>
-            <a:spLocks noGrp="1"/>
-          </p:cNvSpPr>
-          <p:nvPr>
-            <p:ph type="title"/>
-          </p:nvPr>
-        </p:nvSpPr>
-        <p:spPr/>
-        <p:txBody>
-          <a:bodyPr/>
-          <a:lstStyle/>
-          <a:p>
-            <a:pPr lvl="0" indent="0" marL="0">
-              <a:buNone/>
-            </a:pPr>
-            <a:r>
-              <a:rPr/>
-              <a:t>Backup: why three judges?</a:t>
-            </a:r>
-          </a:p>
-        </p:txBody>
-      </p:sp>
-      <p:sp>
-        <p:nvSpPr>
-          <p:cNvPr id="3" name="Content Placeholder 2"/>
-          <p:cNvSpPr>
-            <a:spLocks noGrp="1"/>
-          </p:cNvSpPr>
-          <p:nvPr>
-            <p:ph idx="1"/>
-          </p:nvPr>
-        </p:nvSpPr>
-        <p:spPr/>
-        <p:txBody>
-          <a:bodyPr/>
-          <a:lstStyle/>
-          <a:p>
-            <a:pPr lvl="0"/>
-            <a:r>
-              <a:rPr/>
-              <a:t>Single judge is biased toward its own prior</a:t>
-            </a:r>
-          </a:p>
-          <a:p>
-            <a:pPr lvl="0"/>
-            <a:r>
-              <a:rPr/>
-              <a:t>3 parallel judges + weighted scoring (2 pts first, 1 pt second) hedges </a:t>
-            </a:r>
-            <a:r>
-              <a:rPr i="1"/>
-              <a:t>within</a:t>
-            </a:r>
-            <a:r>
-              <a:rPr/>
-              <a:t> the judging step</a:t>
-            </a:r>
-          </a:p>
-          <a:p>
-            <a:pPr lvl="0"/>
-            <a:r>
-              <a:rPr/>
-              <a:t>Pass@2 format lets the final output also hedge across two interpretations when judges disagree</a:t>
             </a:r>
           </a:p>
         </p:txBody>
@@ -5744,15 +8276,6 @@
           <a:bodyPr/>
           <a:lstStyle/>
           <a:p>
-            <a:pPr lvl="0" indent="0" marL="0">
-              <a:buNone/>
-            </a:pPr>
-            <a:r>
-              <a:rPr b="1"/>
-              <a:t>History of ARC-AGI</a:t>
-            </a:r>
-          </a:p>
-          <a:p>
             <a:pPr lvl="0"/>
             <a:r>
               <a:rPr b="1"/>
@@ -5760,7 +8283,7 @@
             </a:r>
             <a:r>
               <a:rPr/>
-              <a:t> — ARC-AGI-1 introduced (Chollet)</a:t>
+              <a:t> — ARC-AGI-1 introduced (Chollet); trivial for humans, impossible for AI at the time</a:t>
             </a:r>
           </a:p>
           <a:p>
@@ -5771,7 +8294,7 @@
             </a:r>
             <a:r>
               <a:rPr/>
-              <a:t> — Program synthesis era (Icecuber et al.); top scores creep up to ~20% on ARC-AGI-1</a:t>
+              <a:t> — Program synthesis era; top scores reach ~20% on ARC-AGI-1</a:t>
             </a:r>
           </a:p>
           <a:p>
@@ -5782,7 +8305,7 @@
             </a:r>
             <a:r>
               <a:rPr/>
-              <a:t> — OpenAI o3 saturates ARC-AGI-1: ~76% at $200/task</a:t>
+              <a:t> — o3 saturates ARC-AGI-1 (~76% at $200/task), but only ~3% on ARC-AGI-2</a:t>
             </a:r>
           </a:p>
           <a:p>
@@ -5793,7 +8316,7 @@
             </a:r>
             <a:r>
               <a:rPr/>
-              <a:t> — ARC-AGI-2 launches: harder + cost-weighted; top frontier models ~50%</a:t>
+              <a:t> — Focus shifts to ARC-AGI-2; top scores climb to ~50% (GPT-5.2, Opus 4.5)</a:t>
             </a:r>
           </a:p>
           <a:p>
@@ -5808,7 +8331,7 @@
             </a:r>
             <a:r>
               <a:rPr b="1"/>
-              <a:t>This work submitted: 72.9% on ARC-AGI-2</a:t>
+              <a:t>This work: 72.9% on ARC-AGI-2</a:t>
             </a:r>
             <a:r>
               <a:rPr/>
@@ -5823,7 +8346,7 @@
             </a:r>
             <a:r>
               <a:rPr/>
-              <a:t> — Frontier models leapfrog to ~80%+ on ARC-AGI-2 (GPT-5.5, Gemini 3 Deep Think); ARC-AGI-3 launched (top scores still &lt;1%)</a:t>
+              <a:t> — Frontier models leapfrog to ~80%+ (GPT-5.5, Gemini 3.1 Deep Think, Opus 4.7); ARC-AGI-3 launches (&lt;1%)</a:t>
             </a:r>
           </a:p>
         </p:txBody>
@@ -5844,8 +8367,8 @@
         </p:blipFill>
         <p:spPr bwMode="auto">
           <a:xfrm>
-            <a:off x="4699000" y="1193800"/>
-            <a:ext cx="3924300" cy="3390900"/>
+            <a:off x="4648200" y="1270000"/>
+            <a:ext cx="4038600" cy="3238500"/>
           </a:xfrm>
           <a:prstGeom prst="rect">
             <a:avLst/>
@@ -5858,6 +8381,98 @@
           </a:ln>
         </p:spPr>
       </p:pic>
+    </p:spTree>
+  </p:cSld>
+</p:sld>
+</file>
+
+<file path=ppt/slides/slide20.xml><?xml version="1.0" encoding="utf-8"?>
+<p:sld xmlns:a="http://schemas.openxmlformats.org/drawingml/2006/main" xmlns:r="http://schemas.openxmlformats.org/officeDocument/2006/relationships" xmlns:p="http://schemas.openxmlformats.org/presentationml/2006/main">
+  <p:cSld>
+    <p:spTree>
+      <p:nvGrpSpPr>
+        <p:cNvPr id="1" name=""/>
+        <p:cNvGrpSpPr/>
+        <p:nvPr/>
+      </p:nvGrpSpPr>
+      <p:grpSpPr>
+        <a:xfrm>
+          <a:off x="0" y="0"/>
+          <a:ext cx="0" cy="0"/>
+          <a:chOff x="0" y="0"/>
+          <a:chExt cx="0" cy="0"/>
+        </a:xfrm>
+      </p:grpSpPr>
+      <p:sp>
+        <p:nvSpPr>
+          <p:cNvPr id="2" name="Title 1"/>
+          <p:cNvSpPr>
+            <a:spLocks noGrp="1"/>
+          </p:cNvSpPr>
+          <p:nvPr>
+            <p:ph type="title"/>
+          </p:nvPr>
+        </p:nvSpPr>
+        <p:spPr/>
+        <p:txBody>
+          <a:bodyPr/>
+          <a:lstStyle/>
+          <a:p>
+            <a:pPr lvl="0" indent="0" marL="0">
+              <a:buNone/>
+            </a:pPr>
+            <a:r>
+              <a:rPr/>
+              <a:t>Backup: why three judges?</a:t>
+            </a:r>
+          </a:p>
+        </p:txBody>
+      </p:sp>
+      <p:sp>
+        <p:nvSpPr>
+          <p:cNvPr id="3" name="Content Placeholder 2"/>
+          <p:cNvSpPr>
+            <a:spLocks noGrp="1"/>
+          </p:cNvSpPr>
+          <p:nvPr>
+            <p:ph idx="1"/>
+          </p:nvPr>
+        </p:nvSpPr>
+        <p:spPr/>
+        <p:txBody>
+          <a:bodyPr/>
+          <a:lstStyle/>
+          <a:p>
+            <a:pPr lvl="0"/>
+            <a:r>
+              <a:rPr/>
+              <a:t>Single judge is biased toward its own prior</a:t>
+            </a:r>
+          </a:p>
+          <a:p>
+            <a:pPr lvl="0"/>
+            <a:r>
+              <a:rPr/>
+              <a:t>3 parallel judges + weighted scoring (2 pts first, 1 pt second) hedges </a:t>
+            </a:r>
+            <a:r>
+              <a:rPr i="1"/>
+              <a:t>within</a:t>
+            </a:r>
+            <a:r>
+              <a:rPr/>
+              <a:t> the judging step</a:t>
+            </a:r>
+          </a:p>
+          <a:p>
+            <a:pPr lvl="0"/>
+            <a:r>
+              <a:rPr/>
+              <a:t>Pass@2 format lets the final output also hedge across two interpretations when judges disagree</a:t>
+            </a:r>
+          </a:p>
+        </p:txBody>
+      </p:sp>
     </p:spTree>
   </p:cSld>
 </p:sld>
@@ -6216,7 +8831,7 @@
                       </a:pPr>
                       <a:r>
                         <a:rPr b="1"/>
-                        <a:t>This work (semi-private)</a:t>
+                        <a:t>This work (private)</a:t>
                       </a:r>
                     </a:p>
                   </a:txBody>
@@ -6357,53 +8972,6 @@
                       </a:pPr>
                       <a:r>
                         <a:rPr/>
-                        <a:t>Gemini 3 Pro (Refine.)</a:t>
-                      </a:r>
-                    </a:p>
-                  </a:txBody>
-                </a:tc>
-                <a:tc>
-                  <a:txBody>
-                    <a:bodyPr/>
-                    <a:lstStyle/>
-                    <a:p>
-                      <a:pPr lvl="0" indent="0" marL="0" algn="r">
-                        <a:buNone/>
-                      </a:pPr>
-                      <a:r>
-                        <a:rPr/>
-                        <a:t>54.0%</a:t>
-                      </a:r>
-                    </a:p>
-                  </a:txBody>
-                </a:tc>
-                <a:tc>
-                  <a:txBody>
-                    <a:bodyPr/>
-                    <a:lstStyle/>
-                    <a:p>
-                      <a:pPr lvl="0" indent="0" marL="0" algn="r">
-                        <a:buNone/>
-                      </a:pPr>
-                      <a:r>
-                        <a:rPr/>
-                        <a:t>$30.57</a:t>
-                      </a:r>
-                    </a:p>
-                  </a:txBody>
-                </a:tc>
-              </a:tr>
-              <a:tr h="0">
-                <a:tc>
-                  <a:txBody>
-                    <a:bodyPr/>
-                    <a:lstStyle/>
-                    <a:p>
-                      <a:pPr lvl="0" indent="0" marL="0">
-                        <a:buNone/>
-                      </a:pPr>
-                      <a:r>
-                        <a:rPr/>
                         <a:t>Opus 4.5 (Thinking, 64K)</a:t>
                       </a:r>
                     </a:p>
@@ -6440,6 +9008,53 @@
                   </a:txBody>
                 </a:tc>
               </a:tr>
+              <a:tr h="0">
+                <a:tc>
+                  <a:txBody>
+                    <a:bodyPr/>
+                    <a:lstStyle/>
+                    <a:p>
+                      <a:pPr lvl="0" indent="0" marL="0">
+                        <a:buNone/>
+                      </a:pPr>
+                      <a:r>
+                        <a:rPr/>
+                        <a:t>Gemini 3 Pro</a:t>
+                      </a:r>
+                    </a:p>
+                  </a:txBody>
+                </a:tc>
+                <a:tc>
+                  <a:txBody>
+                    <a:bodyPr/>
+                    <a:lstStyle/>
+                    <a:p>
+                      <a:pPr lvl="0" indent="0" marL="0" algn="r">
+                        <a:buNone/>
+                      </a:pPr>
+                      <a:r>
+                        <a:rPr/>
+                        <a:t>31.1%</a:t>
+                      </a:r>
+                    </a:p>
+                  </a:txBody>
+                </a:tc>
+                <a:tc>
+                  <a:txBody>
+                    <a:bodyPr/>
+                    <a:lstStyle/>
+                    <a:p>
+                      <a:pPr lvl="0" indent="0" marL="0" algn="r">
+                        <a:buNone/>
+                      </a:pPr>
+                      <a:r>
+                        <a:rPr/>
+                        <a:t>$0.81</a:t>
+                      </a:r>
+                    </a:p>
+                  </a:txBody>
+                </a:tc>
+              </a:tr>
             </a:tbl>
           </a:graphicData>
         </a:graphic>
@@ -6486,7 +9101,7 @@
             </a:pPr>
             <a:r>
               <a:rPr/>
-              <a:t>The real problem is selection, not generation</a:t>
+              <a:t>Two problems: break groupthink, then recognize the outlier</a:t>
             </a:r>
           </a:p>
         </p:txBody>
@@ -6545,23 +9160,48 @@
           <a:p>
             <a:pPr lvl="0"/>
             <a:r>
-              <a:rPr/>
-              <a:t>The hard problem isn’t generating a correct candidate</a:t>
+              <a:rPr b="1"/>
+              <a:t>(1) Break the groupthink</a:t>
+            </a:r>
+            <a:r>
+              <a:rPr/>
+              <a:t> — diversify so some candidate reaches the correct answer</a:t>
             </a:r>
           </a:p>
           <a:p>
             <a:pPr lvl="0"/>
             <a:r>
-              <a:rPr/>
-              <a:t>It’s </a:t>
-            </a:r>
-            <a:r>
               <a:rPr b="1"/>
-              <a:t>recognizing</a:t>
-            </a:r>
-            <a:r>
-              <a:rPr/>
-              <a:t> one when most others disagree</a:t>
+              <a:t>(2) Recognize the rare-correct</a:t>
+            </a:r>
+            <a:r>
+              <a:rPr/>
+              <a:t> — pick it out when most others disagree</a:t>
+            </a:r>
+          </a:p>
+          <a:p>
+            <a:pPr lvl="0" indent="0" marL="0">
+              <a:buNone/>
+            </a:pPr>
+            <a:r>
+              <a:rPr i="1"/>
+              <a:t>Roadmap: </a:t>
+            </a:r>
+            <a:r>
+              <a:rPr b="1" i="1"/>
+              <a:t>(1)</a:t>
+            </a:r>
+            <a:r>
+              <a:rPr i="1"/>
+              <a:t> next two slides · </a:t>
+            </a:r>
+            <a:r>
+              <a:rPr b="1" i="1"/>
+              <a:t>(2)</a:t>
+            </a:r>
+            <a:r>
+              <a:rPr i="1"/>
+              <a:t> after that · then both wired together · then on a real task</a:t>
             </a:r>
           </a:p>
         </p:txBody>
@@ -6608,7 +9248,7 @@
             </a:pPr>
             <a:r>
               <a:rPr/>
-              <a:t>Core idea: modalities as search operators</a:t>
+              <a:t>(1) Break the groupthink — modalities as search operators</a:t>
             </a:r>
           </a:p>
         </p:txBody>
@@ -6756,7 +9396,262 @@
             </a:pPr>
             <a:r>
               <a:rPr/>
-              <a:t>Pipeline overview</a:t>
+              <a:t>(1) Break the groupthink — candidate generation in practice</a:t>
+            </a:r>
+          </a:p>
+        </p:txBody>
+      </p:sp>
+      <p:sp>
+        <p:nvSpPr>
+          <p:cNvPr id="3" name="Content Placeholder 2"/>
+          <p:cNvSpPr>
+            <a:spLocks noGrp="1"/>
+          </p:cNvSpPr>
+          <p:nvPr>
+            <p:ph idx="1"/>
+          </p:nvPr>
+        </p:nvSpPr>
+        <p:spPr/>
+        <p:txBody>
+          <a:bodyPr/>
+          <a:lstStyle/>
+          <a:p>
+            <a:pPr lvl="0"/>
+            <a:r>
+              <a:rPr b="1"/>
+              <a:t>3 models:</a:t>
+            </a:r>
+            <a:r>
+              <a:rPr/>
+              <a:t> GPT-5.2 (x-high), Gemini 3 Preview (high), Claude Opus 4.5 (long-context)</a:t>
+            </a:r>
+          </a:p>
+          <a:p>
+            <a:pPr lvl="0"/>
+            <a:r>
+              <a:rPr b="1"/>
+              <a:t>3 modality families:</a:t>
+            </a:r>
+            <a:r>
+              <a:rPr/>
+              <a:t> Text, Image, Code</a:t>
+            </a:r>
+          </a:p>
+          <a:p>
+            <a:pPr lvl="0"/>
+            <a:r>
+              <a:rPr b="1"/>
+              <a:t>29 candidates per task</a:t>
+            </a:r>
+            <a:r>
+              <a:rPr/>
+              <a:t> across families × configurations</a:t>
+            </a:r>
+          </a:p>
+          <a:p>
+            <a:pPr lvl="0"/>
+            <a:r>
+              <a:rPr b="1"/>
+              <a:t>Deliberately minimal prompts</a:t>
+            </a:r>
+            <a:r>
+              <a:rPr/>
+              <a:t> in every lane </a:t>
+            </a:r>
+            <a:r>
+              <a:rPr i="1"/>
+              <a:t>(see slide 10)</a:t>
+            </a:r>
+          </a:p>
+          <a:p>
+            <a:pPr lvl="0"/>
+            <a:r>
+              <a:rPr/>
+              <a:t>Code candidates use a sandbox REPL for iterative debugging</a:t>
+            </a:r>
+          </a:p>
+        </p:txBody>
+      </p:sp>
+    </p:spTree>
+  </p:cSld>
+</p:sld>
+</file>
+
+<file path=ppt/slides/slide8.xml><?xml version="1.0" encoding="utf-8"?>
+<p:sld xmlns:a="http://schemas.openxmlformats.org/drawingml/2006/main" xmlns:r="http://schemas.openxmlformats.org/officeDocument/2006/relationships" xmlns:p="http://schemas.openxmlformats.org/presentationml/2006/main">
+  <p:cSld>
+    <p:spTree>
+      <p:nvGrpSpPr>
+        <p:cNvPr id="1" name=""/>
+        <p:cNvGrpSpPr/>
+        <p:nvPr/>
+      </p:nvGrpSpPr>
+      <p:grpSpPr>
+        <a:xfrm>
+          <a:off x="0" y="0"/>
+          <a:ext cx="0" cy="0"/>
+          <a:chOff x="0" y="0"/>
+          <a:chExt cx="0" cy="0"/>
+        </a:xfrm>
+      </p:grpSpPr>
+      <p:sp>
+        <p:nvSpPr>
+          <p:cNvPr id="2" name="Title 1"/>
+          <p:cNvSpPr>
+            <a:spLocks noGrp="1"/>
+          </p:cNvSpPr>
+          <p:nvPr>
+            <p:ph type="title"/>
+          </p:nvPr>
+        </p:nvSpPr>
+        <p:spPr/>
+        <p:txBody>
+          <a:bodyPr/>
+          <a:lstStyle/>
+          <a:p>
+            <a:pPr lvl="0" indent="0" marL="0">
+              <a:buNone/>
+            </a:pPr>
+            <a:r>
+              <a:rPr/>
+              <a:t>(2) Recognize the rare-correct — holistic judging vs. majority voting</a:t>
+            </a:r>
+          </a:p>
+        </p:txBody>
+      </p:sp>
+      <p:sp>
+        <p:nvSpPr>
+          <p:cNvPr id="3" name="Content Placeholder 2"/>
+          <p:cNvSpPr>
+            <a:spLocks noGrp="1"/>
+          </p:cNvSpPr>
+          <p:nvPr>
+            <p:ph idx="1"/>
+          </p:nvPr>
+        </p:nvSpPr>
+        <p:spPr/>
+        <p:txBody>
+          <a:bodyPr/>
+          <a:lstStyle/>
+          <a:p>
+            <a:pPr lvl="0"/>
+            <a:r>
+              <a:rPr/>
+              <a:t>Concatenate all 29 reasoning traces into one long-context judge prompt</a:t>
+            </a:r>
+          </a:p>
+          <a:p>
+            <a:pPr lvl="0"/>
+            <a:r>
+              <a:rPr/>
+              <a:t>Each judge picks top-2 candidates </a:t>
+            </a:r>
+            <a:r>
+              <a:rPr i="1"/>
+              <a:t>and</a:t>
+            </a:r>
+            <a:r>
+              <a:rPr/>
+              <a:t> explains why other clusters are wrong</a:t>
+            </a:r>
+          </a:p>
+          <a:p>
+            <a:pPr lvl="0"/>
+            <a:r>
+              <a:rPr/>
+              <a:t>Weighted vote across 3 judges → pass@2 guesses</a:t>
+            </a:r>
+          </a:p>
+          <a:p>
+            <a:pPr lvl="0" indent="0" marL="0">
+              <a:buNone/>
+            </a:pPr>
+            <a:r>
+              <a:rPr b="1"/>
+              <a:t>Net uplift vs. majority-vote baseline: +7 instances</a:t>
+            </a:r>
+          </a:p>
+          <a:p>
+            <a:pPr lvl="0" indent="0" marL="0">
+              <a:buNone/>
+            </a:pPr>
+            <a:r>
+              <a:rPr i="1"/>
+              <a:t>All 7 are minority recoveries — the correct answer wasn’t the most common candidate.</a:t>
+            </a:r>
+          </a:p>
+          <a:p>
+            <a:pPr lvl="0" indent="0" marL="0">
+              <a:buNone/>
+            </a:pPr>
+            <a:r>
+              <a:rPr/>
+              <a:t>Plus </a:t>
+            </a:r>
+            <a:r>
+              <a:rPr b="1"/>
+              <a:t>+1 synthesis</a:t>
+            </a:r>
+            <a:r>
+              <a:rPr/>
+              <a:t> instance (</a:t>
+            </a:r>
+            <a:r>
+              <a:rPr>
+                <a:latin typeface="Courier"/>
+              </a:rPr>
+              <a:t>21897d95:2</a:t>
+            </a:r>
+            <a:r>
+              <a:rPr/>
+              <a:t>): zero correct candidates — judge recombined partial insights into a novel correct output.</a:t>
+            </a:r>
+          </a:p>
+        </p:txBody>
+      </p:sp>
+    </p:spTree>
+  </p:cSld>
+</p:sld>
+</file>
+
+<file path=ppt/slides/slide9.xml><?xml version="1.0" encoding="utf-8"?>
+<p:sld xmlns:a="http://schemas.openxmlformats.org/drawingml/2006/main" xmlns:r="http://schemas.openxmlformats.org/officeDocument/2006/relationships" xmlns:p="http://schemas.openxmlformats.org/presentationml/2006/main">
+  <p:cSld>
+    <p:spTree>
+      <p:nvGrpSpPr>
+        <p:cNvPr id="1" name=""/>
+        <p:cNvGrpSpPr/>
+        <p:nvPr/>
+      </p:nvGrpSpPr>
+      <p:grpSpPr>
+        <a:xfrm>
+          <a:off x="0" y="0"/>
+          <a:ext cx="0" cy="0"/>
+          <a:chOff x="0" y="0"/>
+          <a:chExt cx="0" cy="0"/>
+        </a:xfrm>
+      </p:grpSpPr>
+      <p:sp>
+        <p:nvSpPr>
+          <p:cNvPr id="2" name="Title 1"/>
+          <p:cNvSpPr>
+            <a:spLocks noGrp="1"/>
+          </p:cNvSpPr>
+          <p:nvPr>
+            <p:ph type="title"/>
+          </p:nvPr>
+        </p:nvSpPr>
+        <p:spPr/>
+        <p:txBody>
+          <a:bodyPr/>
+          <a:lstStyle/>
+          <a:p>
+            <a:pPr lvl="0" indent="0" marL="0">
+              <a:buNone/>
+            </a:pPr>
+            <a:r>
+              <a:rPr/>
+              <a:t>(1) + (2) wired together — pipeline overview</a:t>
             </a:r>
           </a:p>
         </p:txBody>
@@ -6852,261 +9747,6 @@
             <a:r>
               <a:rPr b="1"/>
               <a:t>36 correct (97%)</a:t>
-            </a:r>
-          </a:p>
-        </p:txBody>
-      </p:sp>
-    </p:spTree>
-  </p:cSld>
-</p:sld>
-</file>
-
-<file path=ppt/slides/slide8.xml><?xml version="1.0" encoding="utf-8"?>
-<p:sld xmlns:a="http://schemas.openxmlformats.org/drawingml/2006/main" xmlns:r="http://schemas.openxmlformats.org/officeDocument/2006/relationships" xmlns:p="http://schemas.openxmlformats.org/presentationml/2006/main">
-  <p:cSld>
-    <p:spTree>
-      <p:nvGrpSpPr>
-        <p:cNvPr id="1" name=""/>
-        <p:cNvGrpSpPr/>
-        <p:nvPr/>
-      </p:nvGrpSpPr>
-      <p:grpSpPr>
-        <a:xfrm>
-          <a:off x="0" y="0"/>
-          <a:ext cx="0" cy="0"/>
-          <a:chOff x="0" y="0"/>
-          <a:chExt cx="0" cy="0"/>
-        </a:xfrm>
-      </p:grpSpPr>
-      <p:sp>
-        <p:nvSpPr>
-          <p:cNvPr id="2" name="Title 1"/>
-          <p:cNvSpPr>
-            <a:spLocks noGrp="1"/>
-          </p:cNvSpPr>
-          <p:nvPr>
-            <p:ph type="title"/>
-          </p:nvPr>
-        </p:nvSpPr>
-        <p:spPr/>
-        <p:txBody>
-          <a:bodyPr/>
-          <a:lstStyle/>
-          <a:p>
-            <a:pPr lvl="0" indent="0" marL="0">
-              <a:buNone/>
-            </a:pPr>
-            <a:r>
-              <a:rPr/>
-              <a:t>Candidate generation in practice</a:t>
-            </a:r>
-          </a:p>
-        </p:txBody>
-      </p:sp>
-      <p:sp>
-        <p:nvSpPr>
-          <p:cNvPr id="3" name="Content Placeholder 2"/>
-          <p:cNvSpPr>
-            <a:spLocks noGrp="1"/>
-          </p:cNvSpPr>
-          <p:nvPr>
-            <p:ph idx="1"/>
-          </p:nvPr>
-        </p:nvSpPr>
-        <p:spPr/>
-        <p:txBody>
-          <a:bodyPr/>
-          <a:lstStyle/>
-          <a:p>
-            <a:pPr lvl="0"/>
-            <a:r>
-              <a:rPr b="1"/>
-              <a:t>3 models:</a:t>
-            </a:r>
-            <a:r>
-              <a:rPr/>
-              <a:t> GPT-5.2 (x-high), Gemini 3 Preview (high), Claude Opus 4.5 (long-context)</a:t>
-            </a:r>
-          </a:p>
-          <a:p>
-            <a:pPr lvl="0"/>
-            <a:r>
-              <a:rPr b="1"/>
-              <a:t>3 modality families:</a:t>
-            </a:r>
-            <a:r>
-              <a:rPr/>
-              <a:t> Text, Image, Code</a:t>
-            </a:r>
-          </a:p>
-          <a:p>
-            <a:pPr lvl="0"/>
-            <a:r>
-              <a:rPr b="1"/>
-              <a:t>29 candidates per task</a:t>
-            </a:r>
-            <a:r>
-              <a:rPr/>
-              <a:t> across families × configurations</a:t>
-            </a:r>
-          </a:p>
-          <a:p>
-            <a:pPr lvl="0"/>
-            <a:r>
-              <a:rPr b="1"/>
-              <a:t>Deliberately minimal prompts</a:t>
-            </a:r>
-            <a:r>
-              <a:rPr/>
-              <a:t> in every lane </a:t>
-            </a:r>
-            <a:r>
-              <a:rPr i="1"/>
-              <a:t>(see slide 10)</a:t>
-            </a:r>
-          </a:p>
-          <a:p>
-            <a:pPr lvl="0"/>
-            <a:r>
-              <a:rPr/>
-              <a:t>Code candidates use a sandbox REPL for iterative debugging</a:t>
-            </a:r>
-          </a:p>
-        </p:txBody>
-      </p:sp>
-    </p:spTree>
-  </p:cSld>
-</p:sld>
-</file>
-
-<file path=ppt/slides/slide9.xml><?xml version="1.0" encoding="utf-8"?>
-<p:sld xmlns:a="http://schemas.openxmlformats.org/drawingml/2006/main" xmlns:r="http://schemas.openxmlformats.org/officeDocument/2006/relationships" xmlns:p="http://schemas.openxmlformats.org/presentationml/2006/main">
-  <p:cSld>
-    <p:spTree>
-      <p:nvGrpSpPr>
-        <p:cNvPr id="1" name=""/>
-        <p:cNvGrpSpPr/>
-        <p:nvPr/>
-      </p:nvGrpSpPr>
-      <p:grpSpPr>
-        <a:xfrm>
-          <a:off x="0" y="0"/>
-          <a:ext cx="0" cy="0"/>
-          <a:chOff x="0" y="0"/>
-          <a:chExt cx="0" cy="0"/>
-        </a:xfrm>
-      </p:grpSpPr>
-      <p:sp>
-        <p:nvSpPr>
-          <p:cNvPr id="2" name="Title 1"/>
-          <p:cNvSpPr>
-            <a:spLocks noGrp="1"/>
-          </p:cNvSpPr>
-          <p:nvPr>
-            <p:ph type="title"/>
-          </p:nvPr>
-        </p:nvSpPr>
-        <p:spPr/>
-        <p:txBody>
-          <a:bodyPr/>
-          <a:lstStyle/>
-          <a:p>
-            <a:pPr lvl="0" indent="0" marL="0">
-              <a:buNone/>
-            </a:pPr>
-            <a:r>
-              <a:rPr/>
-              <a:t>Holistic judging vs. majority voting</a:t>
-            </a:r>
-          </a:p>
-        </p:txBody>
-      </p:sp>
-      <p:sp>
-        <p:nvSpPr>
-          <p:cNvPr id="3" name="Content Placeholder 2"/>
-          <p:cNvSpPr>
-            <a:spLocks noGrp="1"/>
-          </p:cNvSpPr>
-          <p:nvPr>
-            <p:ph idx="1"/>
-          </p:nvPr>
-        </p:nvSpPr>
-        <p:spPr/>
-        <p:txBody>
-          <a:bodyPr/>
-          <a:lstStyle/>
-          <a:p>
-            <a:pPr lvl="0"/>
-            <a:r>
-              <a:rPr/>
-              <a:t>Concatenate all 29 reasoning traces into one long-context judge prompt</a:t>
-            </a:r>
-          </a:p>
-          <a:p>
-            <a:pPr lvl="0"/>
-            <a:r>
-              <a:rPr/>
-              <a:t>Each judge picks top-2 candidates </a:t>
-            </a:r>
-            <a:r>
-              <a:rPr i="1"/>
-              <a:t>and</a:t>
-            </a:r>
-            <a:r>
-              <a:rPr/>
-              <a:t> explains why other clusters are wrong</a:t>
-            </a:r>
-          </a:p>
-          <a:p>
-            <a:pPr lvl="0"/>
-            <a:r>
-              <a:rPr/>
-              <a:t>Weighted vote across 3 judges → pass@2 guesses</a:t>
-            </a:r>
-          </a:p>
-          <a:p>
-            <a:pPr lvl="0" indent="0" marL="0">
-              <a:buNone/>
-            </a:pPr>
-            <a:r>
-              <a:rPr b="1"/>
-              <a:t>Net uplift vs. majority-vote baseline: +7 instances</a:t>
-            </a:r>
-          </a:p>
-          <a:p>
-            <a:pPr lvl="0" indent="0" marL="0">
-              <a:buNone/>
-            </a:pPr>
-            <a:r>
-              <a:rPr i="1"/>
-              <a:t>All 7 are minority recoveries — the correct answer wasn’t the most common candidate.</a:t>
-            </a:r>
-          </a:p>
-          <a:p>
-            <a:pPr lvl="0" indent="0" marL="0">
-              <a:buNone/>
-            </a:pPr>
-            <a:r>
-              <a:rPr/>
-              <a:t>Plus </a:t>
-            </a:r>
-            <a:r>
-              <a:rPr b="1"/>
-              <a:t>+1 synthesis</a:t>
-            </a:r>
-            <a:r>
-              <a:rPr/>
-              <a:t> instance (</a:t>
-            </a:r>
-            <a:r>
-              <a:rPr>
-                <a:latin typeface="Courier"/>
-              </a:rPr>
-              <a:t>21897d95:2</a:t>
-            </a:r>
-            <a:r>
-              <a:rPr/>
-              <a:t>): zero correct candidates — judge recombined partial insights into a novel correct output.</a:t>
             </a:r>
           </a:p>
         </p:txBody>

</xml_diff>